<commit_message>
BPMN/CMMN/DMN: fix slide-outline parser (deel-20 slide 3 werd overgeslagen)
Regex voor slidekoppen ankerde op einde-van-regel; slide 3 in deel-20 heeft
een trailing cursieve aantekening na de kop, waardoor die slide niet werd
herkend (22 aangekondigd, 21 gegenereerd). Alle 30 slidedecks opnieuw
gebouwd en geverifieerd tegen het aangekondigde aantal in de bronmarkdown.
</commit_message>
<xml_diff>
--- a/bpmn-cmmn-dmn/niveau-2/deel-20/slidedeck.pptx
+++ b/bpmn-cmmn-dmn/niveau-2/deel-20/slidedeck.pptx
@@ -26,9 +26,10 @@
     <p:sldId id="274" r:id="rId20"/>
     <p:sldId id="275" r:id="rId21"/>
     <p:sldId id="276" r:id="rId22"/>
+    <p:sldId id="277" r:id="rId23"/>
   </p:sldIdLst>
   <p:notesMasterIdLst>
-    <p:notesMasterId r:id="rId23"/>
+    <p:notesMasterId r:id="rId24"/>
   </p:notesMasterIdLst>
   <p:sldSz cx="12192000" cy="6858000"/>
   <p:notesSz cx="6858000" cy="12192000"/>
@@ -1690,6 +1691,94 @@
             <a:fld id="{F7021451-1387-4CA6-816F-3879F97B5CBC}" type="slidenum">
               <a:rPr lang="en-US"/>
               <a:t>21</a:t>
+            </a:fld>
+            <a:endParaRPr lang="en-US"/>
+          </a:p>
+        </p:txBody>
+      </p:sp>
+    </p:spTree>
+    <p:extLst>
+      <p:ext uri="{BB962C8B-B14F-4D97-AF65-F5344CB8AC3E}">
+        <p14:creationId xmlns:p14="http://schemas.microsoft.com/office/powerpoint/2010/main" val="1024086991"/>
+      </p:ext>
+    </p:extLst>
+  </p:cSld>
+  <p:clrMapOvr>
+    <a:masterClrMapping/>
+  </p:clrMapOvr>
+</p:notes>
+</file>
+
+<file path=ppt/notesSlides/notesSlide22.xml><?xml version="1.0" encoding="utf-8"?>
+<p:notes xmlns:a="http://schemas.openxmlformats.org/drawingml/2006/main" xmlns:r="http://schemas.openxmlformats.org/officeDocument/2006/relationships" xmlns:p="http://schemas.openxmlformats.org/presentationml/2006/main">
+  <p:cSld>
+    <p:spTree>
+      <p:nvGrpSpPr>
+        <p:cNvPr id="1" name=""/>
+        <p:cNvGrpSpPr/>
+        <p:nvPr/>
+      </p:nvGrpSpPr>
+      <p:grpSpPr>
+        <a:xfrm>
+          <a:off x="0" y="0"/>
+          <a:ext cx="0" cy="0"/>
+          <a:chOff x="0" y="0"/>
+          <a:chExt cx="0" cy="0"/>
+        </a:xfrm>
+      </p:grpSpPr>
+      <p:sp>
+        <p:nvSpPr>
+          <p:cNvPr id="2" name="Slide Image Placeholder 1"/>
+          <p:cNvSpPr>
+            <a:spLocks noGrp="1" noRot="1" noChangeAspect="1"/>
+          </p:cNvSpPr>
+          <p:nvPr>
+            <p:ph type="sldImg"/>
+          </p:nvPr>
+        </p:nvSpPr>
+        <p:spPr/>
+      </p:sp>
+      <p:sp>
+        <p:nvSpPr>
+          <p:cNvPr id="3" name="Notes Placeholder 2"/>
+          <p:cNvSpPr>
+            <a:spLocks noGrp="1"/>
+          </p:cNvSpPr>
+          <p:nvPr>
+            <p:ph type="body" idx="1"/>
+          </p:nvPr>
+        </p:nvSpPr>
+        <p:spPr/>
+        <p:txBody>
+          <a:bodyPr/>
+          <a:lstStyle/>
+          <a:p>
+            <a:r>
+              <a:rPr lang="en-US" dirty="0"/>
+              <a:t/>
+            </a:r>
+            <a:endParaRPr lang="en-US" dirty="0"/>
+          </a:p>
+        </p:txBody>
+      </p:sp>
+      <p:sp>
+        <p:nvSpPr>
+          <p:cNvPr id="4" name="Slide Number Placeholder 3"/>
+          <p:cNvSpPr>
+            <a:spLocks noGrp="1"/>
+          </p:cNvSpPr>
+          <p:nvPr>
+            <p:ph type="sldNum" sz="quarter" idx="10"/>
+          </p:nvPr>
+        </p:nvSpPr>
+        <p:spPr/>
+        <p:txBody>
+          <a:bodyPr/>
+          <a:lstStyle/>
+          <a:p>
+            <a:fld id="{F7021451-1387-4CA6-816F-3879F97B5CBC}" type="slidenum">
+              <a:rPr lang="en-US"/>
+              <a:t>22</a:t>
             </a:fld>
             <a:endParaRPr lang="en-US"/>
           </a:p>
@@ -2876,7 +2965,7 @@
                 <a:ea typeface="Calibri" pitchFamily="34" charset="-122"/>
                 <a:cs typeface="Calibri" pitchFamily="34" charset="-120"/>
               </a:rPr>
-              <a:t>Ontbrekende stappen · toegevoegde stappen · afwijkende volgorde</a:t>
+              <a:t>Conformance checking</a:t>
             </a:r>
             <a:endParaRPr lang="en-US" sz="2400" dirty="0"/>
           </a:p>
@@ -2939,7 +3028,7 @@
                 <a:ea typeface="Calibri" pitchFamily="34" charset="-122"/>
                 <a:cs typeface="Calibri" pitchFamily="34" charset="-120"/>
               </a:rPr>
-              <a:t>ingevuld</a:t>
+              <a:t>leeg</a:t>
             </a:r>
             <a:endParaRPr lang="en-US" sz="1200" dirty="0"/>
           </a:p>
@@ -2998,7 +3087,7 @@
                 <a:ea typeface="Calibri" pitchFamily="34" charset="-122"/>
                 <a:cs typeface="Calibri" pitchFamily="34" charset="-120"/>
               </a:rPr>
-              <a:t>Spreeknotitie: Een score, geen absoluut oordeel.</a:t>
+              <a:t>Spreeknotitie: Introductie.</a:t>
             </a:r>
             <a:endParaRPr lang="en-US" sz="1050" dirty="0"/>
           </a:p>
@@ -3069,140 +3158,98 @@
                 <a:ea typeface="Calibri" pitchFamily="34" charset="-122"/>
                 <a:cs typeface="Calibri" pitchFamily="34" charset="-120"/>
               </a:rPr>
-              <a:t>Clusteren op frequentie</a:t>
+              <a:t>Ontbrekende stappen · toegevoegde stappen · afwijkende volgorde</a:t>
             </a:r>
             <a:endParaRPr lang="en-US" sz="2400" dirty="0"/>
           </a:p>
         </p:txBody>
       </p:sp>
-      <p:sp>
-        <p:nvSpPr>
-          <p:cNvPr id="3" name="Shape 1"/>
-          <p:cNvSpPr/>
-          <p:nvPr/>
-        </p:nvSpPr>
-        <p:spPr>
-          <a:xfrm>
-            <a:off x="822960" y="1371600"/>
-            <a:ext cx="10515600" cy="4206240"/>
-          </a:xfrm>
-          <a:prstGeom prst="roundRect">
-            <a:avLst>
-              <a:gd name="adj" fmla="val 1304"/>
-            </a:avLst>
+      <p:pic>
+        <p:nvPicPr>
+          <p:cNvPr id="3" name="Image 0" descr="C:\Projecten\eductus-trainingen\CMMN_BPMN_DMN\cursus-bpmn-cmmn-dmn\build\png\deel-20\figuur-20-4-conformance-uitkomst.png">    </p:cNvPr>
+          <p:cNvPicPr>
+            <a:picLocks noChangeAspect="1"/>
+          </p:cNvPicPr>
+          <p:nvPr/>
+        </p:nvPicPr>
+        <p:blipFill>
+          <a:blip r:embed="rId1"/>
+          <a:stretch>
+            <a:fillRect/>
+          </a:stretch>
+        </p:blipFill>
+        <p:spPr>
+          <a:xfrm>
+            <a:off x="2566244" y="1234440"/>
+            <a:ext cx="7056463" cy="4114800"/>
+          </a:xfrm>
+          <a:prstGeom prst="rect">
+            <a:avLst/>
+          </a:prstGeom>
+        </p:spPr>
+      </p:pic>
+      <p:sp>
+        <p:nvSpPr>
+          <p:cNvPr id="4" name="Text 1"/>
+          <p:cNvSpPr/>
+          <p:nvPr/>
+        </p:nvSpPr>
+        <p:spPr>
+          <a:xfrm>
+            <a:off x="731520" y="5440680"/>
+            <a:ext cx="10698480" cy="457200"/>
+          </a:xfrm>
+          <a:prstGeom prst="rect">
+            <a:avLst/>
+          </a:prstGeom>
+          <a:noFill/>
+          <a:ln/>
+        </p:spPr>
+        <p:txBody>
+          <a:bodyPr wrap="square" rtlCol="0" anchor="ctr"/>
+          <a:lstStyle/>
+          <a:p>
+            <a:pPr algn="ctr" indent="0" marL="0">
+              <a:buNone/>
+            </a:pPr>
+            <a:r>
+              <a:rPr lang="en-US" sz="1200" i="1" dirty="0">
+                <a:solidFill>
+                  <a:srgbClr val="6B7280"/>
+                </a:solidFill>
+                <a:latin typeface="Calibri" pitchFamily="34" charset="0"/>
+                <a:ea typeface="Calibri" pitchFamily="34" charset="-122"/>
+                <a:cs typeface="Calibri" pitchFamily="34" charset="-120"/>
+              </a:rPr>
+              <a:t>ingevuld</a:t>
+            </a:r>
+            <a:endParaRPr lang="en-US" sz="1200" dirty="0"/>
+          </a:p>
+        </p:txBody>
+      </p:sp>
+      <p:sp>
+        <p:nvSpPr>
+          <p:cNvPr id="5" name="Shape 2"/>
+          <p:cNvSpPr/>
+          <p:nvPr/>
+        </p:nvSpPr>
+        <p:spPr>
+          <a:xfrm>
+            <a:off x="0" y="6172200"/>
+            <a:ext cx="12188952" cy="685800"/>
+          </a:xfrm>
+          <a:prstGeom prst="rect">
+            <a:avLst/>
           </a:prstGeom>
           <a:solidFill>
             <a:srgbClr val="EEF1F6"/>
           </a:solidFill>
-          <a:ln w="12700">
-            <a:solidFill>
-              <a:srgbClr val="D7DCE5"/>
-            </a:solidFill>
-            <a:prstDash val="solid"/>
-          </a:ln>
-        </p:spPr>
-      </p:sp>
-      <p:sp>
-        <p:nvSpPr>
-          <p:cNvPr id="4" name="Text 2"/>
-          <p:cNvSpPr/>
-          <p:nvPr/>
-        </p:nvSpPr>
-        <p:spPr>
-          <a:xfrm>
-            <a:off x="1188720" y="1645920"/>
-            <a:ext cx="2743200" cy="365760"/>
-          </a:xfrm>
-          <a:prstGeom prst="rect">
-            <a:avLst/>
-          </a:prstGeom>
-          <a:noFill/>
-          <a:ln/>
-        </p:spPr>
-        <p:txBody>
-          <a:bodyPr wrap="square" rtlCol="0" anchor="ctr"/>
-          <a:lstStyle/>
-          <a:p>
-            <a:pPr indent="0" marL="0">
-              <a:buNone/>
-            </a:pPr>
-            <a:r>
-              <a:rPr lang="en-US" sz="1200" b="1" spc="200" kern="0" dirty="0">
-                <a:solidFill>
-                  <a:srgbClr val="E9A13B"/>
-                </a:solidFill>
-                <a:latin typeface="Calibri" pitchFamily="34" charset="0"/>
-                <a:ea typeface="Calibri" pitchFamily="34" charset="-122"/>
-                <a:cs typeface="Calibri" pitchFamily="34" charset="-120"/>
-              </a:rPr>
-              <a:t>BEELD</a:t>
-            </a:r>
-            <a:endParaRPr lang="en-US" sz="1200" dirty="0"/>
-          </a:p>
-        </p:txBody>
-      </p:sp>
-      <p:sp>
-        <p:nvSpPr>
-          <p:cNvPr id="5" name="Text 3"/>
-          <p:cNvSpPr/>
-          <p:nvPr/>
-        </p:nvSpPr>
-        <p:spPr>
-          <a:xfrm>
-            <a:off x="1188720" y="2103120"/>
-            <a:ext cx="9784080" cy="3200400"/>
-          </a:xfrm>
-          <a:prstGeom prst="rect">
-            <a:avLst/>
-          </a:prstGeom>
-          <a:noFill/>
-          <a:ln/>
-        </p:spPr>
-        <p:txBody>
-          <a:bodyPr wrap="square" rtlCol="0" anchor="t"/>
-          <a:lstStyle/>
-          <a:p>
-            <a:pPr indent="0" marL="0">
-              <a:buNone/>
-            </a:pPr>
-            <a:r>
-              <a:rPr lang="en-US" sz="1800" i="1" dirty="0">
-                <a:solidFill>
-                  <a:srgbClr val="14213D"/>
-                </a:solidFill>
-                <a:latin typeface="Calibri" pitchFamily="34" charset="0"/>
-                <a:ea typeface="Calibri" pitchFamily="34" charset="-122"/>
-                <a:cs typeface="Calibri" pitchFamily="34" charset="-120"/>
-              </a:rPr>
-              <a:t>Honderd losse afwijkingen versus drie patronen</a:t>
-            </a:r>
-            <a:endParaRPr lang="en-US" sz="1800" dirty="0"/>
-          </a:p>
-        </p:txBody>
-      </p:sp>
-      <p:sp>
-        <p:nvSpPr>
-          <p:cNvPr id="6" name="Shape 4"/>
-          <p:cNvSpPr/>
-          <p:nvPr/>
-        </p:nvSpPr>
-        <p:spPr>
-          <a:xfrm>
-            <a:off x="0" y="6172200"/>
-            <a:ext cx="12188952" cy="685800"/>
-          </a:xfrm>
-          <a:prstGeom prst="rect">
-            <a:avLst/>
-          </a:prstGeom>
-          <a:solidFill>
-            <a:srgbClr val="EEF1F6"/>
-          </a:solidFill>
-          <a:ln/>
-        </p:spPr>
-      </p:sp>
-      <p:sp>
-        <p:nvSpPr>
-          <p:cNvPr id="7" name="Text 5"/>
+          <a:ln/>
+        </p:spPr>
+      </p:sp>
+      <p:sp>
+        <p:nvSpPr>
+          <p:cNvPr id="6" name="Text 3"/>
           <p:cNvSpPr/>
           <p:nvPr/>
         </p:nvSpPr>
@@ -3233,7 +3280,7 @@
                 <a:ea typeface="Calibri" pitchFamily="34" charset="-122"/>
                 <a:cs typeface="Calibri" pitchFamily="34" charset="-120"/>
               </a:rPr>
-              <a:t>Spreeknotitie: De vaardigheid zit in het patroon zien, niet in elk geval apart bekijken.</a:t>
+              <a:t>Spreeknotitie: Een score, geen absoluut oordeel.</a:t>
             </a:r>
             <a:endParaRPr lang="en-US" sz="1050" dirty="0"/>
           </a:p>
@@ -3304,7 +3351,7 @@
                 <a:ea typeface="Calibri" pitchFamily="34" charset="-122"/>
                 <a:cs typeface="Calibri" pitchFamily="34" charset="-120"/>
               </a:rPr>
-              <a:t>Eerste conformance-run — Deelnemermutaties</a:t>
+              <a:t>Clusteren op frequentie</a:t>
             </a:r>
             <a:endParaRPr lang="en-US" sz="2400" dirty="0"/>
           </a:p>
@@ -3409,7 +3456,7 @@
                 <a:ea typeface="Calibri" pitchFamily="34" charset="-122"/>
                 <a:cs typeface="Calibri" pitchFamily="34" charset="-120"/>
               </a:rPr>
-              <a:t>Werkboekverwijzing, timer 30 minuten</a:t>
+              <a:t>Honderd losse afwijkingen versus drie patronen</a:t>
             </a:r>
             <a:endParaRPr lang="en-US" sz="1800" dirty="0"/>
           </a:p>
@@ -3468,7 +3515,7 @@
                 <a:ea typeface="Calibri" pitchFamily="34" charset="-122"/>
                 <a:cs typeface="Calibri" pitchFamily="34" charset="-120"/>
               </a:rPr>
-              <a:t>Spreeknotitie: Individueel in Retroductus.</a:t>
+              <a:t>Spreeknotitie: De vaardigheid zit in het patroon zien, niet in elk geval apart bekijken.</a:t>
             </a:r>
             <a:endParaRPr lang="en-US" sz="1050" dirty="0"/>
           </a:p>
@@ -3539,7 +3586,7 @@
                 <a:ea typeface="Calibri" pitchFamily="34" charset="-122"/>
                 <a:cs typeface="Calibri" pitchFamily="34" charset="-120"/>
               </a:rPr>
-              <a:t>Jouw eigen to-be model tegen de werkelijkheid</a:t>
+              <a:t>Eerste conformance-run — Deelnemermutaties</a:t>
             </a:r>
             <a:endParaRPr lang="en-US" sz="2400" dirty="0"/>
           </a:p>
@@ -3644,7 +3691,7 @@
                 <a:ea typeface="Calibri" pitchFamily="34" charset="-122"/>
                 <a:cs typeface="Calibri" pitchFamily="34" charset="-120"/>
               </a:rPr>
-              <a:t>Werkboekverwijzing, timer 20 minuten</a:t>
+              <a:t>Werkboekverwijzing, timer 30 minuten</a:t>
             </a:r>
             <a:endParaRPr lang="en-US" sz="1800" dirty="0"/>
           </a:p>
@@ -3703,7 +3750,7 @@
                 <a:ea typeface="Calibri" pitchFamily="34" charset="-122"/>
                 <a:cs typeface="Calibri" pitchFamily="34" charset="-120"/>
               </a:rPr>
-              <a:t>Spreeknotitie: Individueel. Waarschuw vooraf: een lage score is de bedoeling van deze opdracht, geen falen.</a:t>
+              <a:t>Spreeknotitie: Individueel in Retroductus.</a:t>
             </a:r>
             <a:endParaRPr lang="en-US" sz="1050" dirty="0"/>
           </a:p>
@@ -3774,98 +3821,140 @@
                 <a:ea typeface="Calibri" pitchFamily="34" charset="-122"/>
                 <a:cs typeface="Calibri" pitchFamily="34" charset="-120"/>
               </a:rPr>
-              <a:t>Het model — de uitvoering — of geen van beide</a:t>
+              <a:t>Jouw eigen to-be model tegen de werkelijkheid</a:t>
             </a:r>
             <a:endParaRPr lang="en-US" sz="2400" dirty="0"/>
           </a:p>
         </p:txBody>
       </p:sp>
-      <p:pic>
-        <p:nvPicPr>
-          <p:cNvPr id="3" name="Image 0" descr="C:\Projecten\eductus-trainingen\CMMN_BPMN_DMN\cursus-bpmn-cmmn-dmn\build\png\deel-20\figuur-20-5-wie-heeft-gelijk-beslisboom.png">    </p:cNvPr>
-          <p:cNvPicPr>
-            <a:picLocks noChangeAspect="1"/>
-          </p:cNvPicPr>
-          <p:nvPr/>
-        </p:nvPicPr>
-        <p:blipFill>
-          <a:blip r:embed="rId1"/>
-          <a:stretch>
-            <a:fillRect/>
-          </a:stretch>
-        </p:blipFill>
-        <p:spPr>
-          <a:xfrm>
-            <a:off x="2379081" y="1234440"/>
-            <a:ext cx="7430790" cy="4114800"/>
-          </a:xfrm>
-          <a:prstGeom prst="rect">
-            <a:avLst/>
-          </a:prstGeom>
-        </p:spPr>
-      </p:pic>
-      <p:sp>
-        <p:nvSpPr>
-          <p:cNvPr id="4" name="Text 1"/>
-          <p:cNvSpPr/>
-          <p:nvPr/>
-        </p:nvSpPr>
-        <p:spPr>
-          <a:xfrm>
-            <a:off x="731520" y="5440680"/>
-            <a:ext cx="10698480" cy="457200"/>
-          </a:xfrm>
-          <a:prstGeom prst="rect">
-            <a:avLst/>
-          </a:prstGeom>
-          <a:noFill/>
-          <a:ln/>
-        </p:spPr>
-        <p:txBody>
-          <a:bodyPr wrap="square" rtlCol="0" anchor="ctr"/>
-          <a:lstStyle/>
-          <a:p>
-            <a:pPr algn="ctr" indent="0" marL="0">
-              <a:buNone/>
-            </a:pPr>
-            <a:r>
-              <a:rPr lang="en-US" sz="1200" i="1" dirty="0">
-                <a:solidFill>
-                  <a:srgbClr val="6B7280"/>
-                </a:solidFill>
-                <a:latin typeface="Calibri" pitchFamily="34" charset="0"/>
-                <a:ea typeface="Calibri" pitchFamily="34" charset="-122"/>
-                <a:cs typeface="Calibri" pitchFamily="34" charset="-120"/>
-              </a:rPr>
-              <a:t>leeg</a:t>
-            </a:r>
-            <a:endParaRPr lang="en-US" sz="1200" dirty="0"/>
-          </a:p>
-        </p:txBody>
-      </p:sp>
-      <p:sp>
-        <p:nvSpPr>
-          <p:cNvPr id="5" name="Shape 2"/>
-          <p:cNvSpPr/>
-          <p:nvPr/>
-        </p:nvSpPr>
-        <p:spPr>
-          <a:xfrm>
-            <a:off x="0" y="6172200"/>
-            <a:ext cx="12188952" cy="685800"/>
-          </a:xfrm>
-          <a:prstGeom prst="rect">
-            <a:avLst/>
+      <p:sp>
+        <p:nvSpPr>
+          <p:cNvPr id="3" name="Shape 1"/>
+          <p:cNvSpPr/>
+          <p:nvPr/>
+        </p:nvSpPr>
+        <p:spPr>
+          <a:xfrm>
+            <a:off x="822960" y="1371600"/>
+            <a:ext cx="10515600" cy="4206240"/>
+          </a:xfrm>
+          <a:prstGeom prst="roundRect">
+            <a:avLst>
+              <a:gd name="adj" fmla="val 1304"/>
+            </a:avLst>
           </a:prstGeom>
           <a:solidFill>
             <a:srgbClr val="EEF1F6"/>
           </a:solidFill>
-          <a:ln/>
-        </p:spPr>
-      </p:sp>
-      <p:sp>
-        <p:nvSpPr>
-          <p:cNvPr id="6" name="Text 3"/>
+          <a:ln w="12700">
+            <a:solidFill>
+              <a:srgbClr val="D7DCE5"/>
+            </a:solidFill>
+            <a:prstDash val="solid"/>
+          </a:ln>
+        </p:spPr>
+      </p:sp>
+      <p:sp>
+        <p:nvSpPr>
+          <p:cNvPr id="4" name="Text 2"/>
+          <p:cNvSpPr/>
+          <p:nvPr/>
+        </p:nvSpPr>
+        <p:spPr>
+          <a:xfrm>
+            <a:off x="1188720" y="1645920"/>
+            <a:ext cx="2743200" cy="365760"/>
+          </a:xfrm>
+          <a:prstGeom prst="rect">
+            <a:avLst/>
+          </a:prstGeom>
+          <a:noFill/>
+          <a:ln/>
+        </p:spPr>
+        <p:txBody>
+          <a:bodyPr wrap="square" rtlCol="0" anchor="ctr"/>
+          <a:lstStyle/>
+          <a:p>
+            <a:pPr indent="0" marL="0">
+              <a:buNone/>
+            </a:pPr>
+            <a:r>
+              <a:rPr lang="en-US" sz="1200" b="1" spc="200" kern="0" dirty="0">
+                <a:solidFill>
+                  <a:srgbClr val="E9A13B"/>
+                </a:solidFill>
+                <a:latin typeface="Calibri" pitchFamily="34" charset="0"/>
+                <a:ea typeface="Calibri" pitchFamily="34" charset="-122"/>
+                <a:cs typeface="Calibri" pitchFamily="34" charset="-120"/>
+              </a:rPr>
+              <a:t>BEELD</a:t>
+            </a:r>
+            <a:endParaRPr lang="en-US" sz="1200" dirty="0"/>
+          </a:p>
+        </p:txBody>
+      </p:sp>
+      <p:sp>
+        <p:nvSpPr>
+          <p:cNvPr id="5" name="Text 3"/>
+          <p:cNvSpPr/>
+          <p:nvPr/>
+        </p:nvSpPr>
+        <p:spPr>
+          <a:xfrm>
+            <a:off x="1188720" y="2103120"/>
+            <a:ext cx="9784080" cy="3200400"/>
+          </a:xfrm>
+          <a:prstGeom prst="rect">
+            <a:avLst/>
+          </a:prstGeom>
+          <a:noFill/>
+          <a:ln/>
+        </p:spPr>
+        <p:txBody>
+          <a:bodyPr wrap="square" rtlCol="0" anchor="t"/>
+          <a:lstStyle/>
+          <a:p>
+            <a:pPr indent="0" marL="0">
+              <a:buNone/>
+            </a:pPr>
+            <a:r>
+              <a:rPr lang="en-US" sz="1800" i="1" dirty="0">
+                <a:solidFill>
+                  <a:srgbClr val="14213D"/>
+                </a:solidFill>
+                <a:latin typeface="Calibri" pitchFamily="34" charset="0"/>
+                <a:ea typeface="Calibri" pitchFamily="34" charset="-122"/>
+                <a:cs typeface="Calibri" pitchFamily="34" charset="-120"/>
+              </a:rPr>
+              <a:t>Werkboekverwijzing, timer 20 minuten</a:t>
+            </a:r>
+            <a:endParaRPr lang="en-US" sz="1800" dirty="0"/>
+          </a:p>
+        </p:txBody>
+      </p:sp>
+      <p:sp>
+        <p:nvSpPr>
+          <p:cNvPr id="6" name="Shape 4"/>
+          <p:cNvSpPr/>
+          <p:nvPr/>
+        </p:nvSpPr>
+        <p:spPr>
+          <a:xfrm>
+            <a:off x="0" y="6172200"/>
+            <a:ext cx="12188952" cy="685800"/>
+          </a:xfrm>
+          <a:prstGeom prst="rect">
+            <a:avLst/>
+          </a:prstGeom>
+          <a:solidFill>
+            <a:srgbClr val="EEF1F6"/>
+          </a:solidFill>
+          <a:ln/>
+        </p:spPr>
+      </p:sp>
+      <p:sp>
+        <p:nvSpPr>
+          <p:cNvPr id="7" name="Text 5"/>
           <p:cNvSpPr/>
           <p:nvPr/>
         </p:nvSpPr>
@@ -3896,7 +3985,7 @@
                 <a:ea typeface="Calibri" pitchFamily="34" charset="-122"/>
                 <a:cs typeface="Calibri" pitchFamily="34" charset="-120"/>
               </a:rPr>
-              <a:t>Spreeknotitie: Drie mogelijke verklaringen voor elke afwijking.</a:t>
+              <a:t>Spreeknotitie: Individueel. Waarschuw vooraf: een lage score is de bedoeling van deze opdracht, geen falen.</a:t>
             </a:r>
             <a:endParaRPr lang="en-US" sz="1050" dirty="0"/>
           </a:p>
@@ -3967,7 +4056,7 @@
                 <a:ea typeface="Calibri" pitchFamily="34" charset="-122"/>
                 <a:cs typeface="Calibri" pitchFamily="34" charset="-120"/>
               </a:rPr>
-              <a:t>Een legitieme, nooit vastgelegde variant</a:t>
+              <a:t>Het model — de uitvoering — of geen van beide</a:t>
             </a:r>
             <a:endParaRPr lang="en-US" sz="2400" dirty="0"/>
           </a:p>
@@ -4030,7 +4119,7 @@
                 <a:ea typeface="Calibri" pitchFamily="34" charset="-122"/>
                 <a:cs typeface="Calibri" pitchFamily="34" charset="-120"/>
               </a:rPr>
-              <a:t>derde tak uitgelicht</a:t>
+              <a:t>leeg</a:t>
             </a:r>
             <a:endParaRPr lang="en-US" sz="1200" dirty="0"/>
           </a:p>
@@ -4089,7 +4178,7 @@
                 <a:ea typeface="Calibri" pitchFamily="34" charset="-122"/>
                 <a:cs typeface="Calibri" pitchFamily="34" charset="-120"/>
               </a:rPr>
-              <a:t>Spreeknotitie: Niet fout, niet verouderd — gewoon nooit opgeschreven.</a:t>
+              <a:t>Spreeknotitie: Drie mogelijke verklaringen voor elke afwijking.</a:t>
             </a:r>
             <a:endParaRPr lang="en-US" sz="1050" dirty="0"/>
           </a:p>
@@ -4160,140 +4249,98 @@
                 <a:ea typeface="Calibri" pitchFamily="34" charset="-122"/>
                 <a:cs typeface="Calibri" pitchFamily="34" charset="-120"/>
               </a:rPr>
-              <a:t>Classificeer vijf afwijkingen</a:t>
+              <a:t>Een legitieme, nooit vastgelegde variant</a:t>
             </a:r>
             <a:endParaRPr lang="en-US" sz="2400" dirty="0"/>
           </a:p>
         </p:txBody>
       </p:sp>
-      <p:sp>
-        <p:nvSpPr>
-          <p:cNvPr id="3" name="Shape 1"/>
-          <p:cNvSpPr/>
-          <p:nvPr/>
-        </p:nvSpPr>
-        <p:spPr>
-          <a:xfrm>
-            <a:off x="822960" y="1371600"/>
-            <a:ext cx="10515600" cy="4206240"/>
-          </a:xfrm>
-          <a:prstGeom prst="roundRect">
-            <a:avLst>
-              <a:gd name="adj" fmla="val 1304"/>
-            </a:avLst>
+      <p:pic>
+        <p:nvPicPr>
+          <p:cNvPr id="3" name="Image 0" descr="C:\Projecten\eductus-trainingen\CMMN_BPMN_DMN\cursus-bpmn-cmmn-dmn\build\png\deel-20\figuur-20-5-wie-heeft-gelijk-beslisboom.png">    </p:cNvPr>
+          <p:cNvPicPr>
+            <a:picLocks noChangeAspect="1"/>
+          </p:cNvPicPr>
+          <p:nvPr/>
+        </p:nvPicPr>
+        <p:blipFill>
+          <a:blip r:embed="rId1"/>
+          <a:stretch>
+            <a:fillRect/>
+          </a:stretch>
+        </p:blipFill>
+        <p:spPr>
+          <a:xfrm>
+            <a:off x="2379081" y="1234440"/>
+            <a:ext cx="7430790" cy="4114800"/>
+          </a:xfrm>
+          <a:prstGeom prst="rect">
+            <a:avLst/>
+          </a:prstGeom>
+        </p:spPr>
+      </p:pic>
+      <p:sp>
+        <p:nvSpPr>
+          <p:cNvPr id="4" name="Text 1"/>
+          <p:cNvSpPr/>
+          <p:nvPr/>
+        </p:nvSpPr>
+        <p:spPr>
+          <a:xfrm>
+            <a:off x="731520" y="5440680"/>
+            <a:ext cx="10698480" cy="457200"/>
+          </a:xfrm>
+          <a:prstGeom prst="rect">
+            <a:avLst/>
+          </a:prstGeom>
+          <a:noFill/>
+          <a:ln/>
+        </p:spPr>
+        <p:txBody>
+          <a:bodyPr wrap="square" rtlCol="0" anchor="ctr"/>
+          <a:lstStyle/>
+          <a:p>
+            <a:pPr algn="ctr" indent="0" marL="0">
+              <a:buNone/>
+            </a:pPr>
+            <a:r>
+              <a:rPr lang="en-US" sz="1200" i="1" dirty="0">
+                <a:solidFill>
+                  <a:srgbClr val="6B7280"/>
+                </a:solidFill>
+                <a:latin typeface="Calibri" pitchFamily="34" charset="0"/>
+                <a:ea typeface="Calibri" pitchFamily="34" charset="-122"/>
+                <a:cs typeface="Calibri" pitchFamily="34" charset="-120"/>
+              </a:rPr>
+              <a:t>derde tak uitgelicht</a:t>
+            </a:r>
+            <a:endParaRPr lang="en-US" sz="1200" dirty="0"/>
+          </a:p>
+        </p:txBody>
+      </p:sp>
+      <p:sp>
+        <p:nvSpPr>
+          <p:cNvPr id="5" name="Shape 2"/>
+          <p:cNvSpPr/>
+          <p:nvPr/>
+        </p:nvSpPr>
+        <p:spPr>
+          <a:xfrm>
+            <a:off x="0" y="6172200"/>
+            <a:ext cx="12188952" cy="685800"/>
+          </a:xfrm>
+          <a:prstGeom prst="rect">
+            <a:avLst/>
           </a:prstGeom>
           <a:solidFill>
             <a:srgbClr val="EEF1F6"/>
           </a:solidFill>
-          <a:ln w="12700">
-            <a:solidFill>
-              <a:srgbClr val="D7DCE5"/>
-            </a:solidFill>
-            <a:prstDash val="solid"/>
-          </a:ln>
-        </p:spPr>
-      </p:sp>
-      <p:sp>
-        <p:nvSpPr>
-          <p:cNvPr id="4" name="Text 2"/>
-          <p:cNvSpPr/>
-          <p:nvPr/>
-        </p:nvSpPr>
-        <p:spPr>
-          <a:xfrm>
-            <a:off x="1188720" y="1645920"/>
-            <a:ext cx="2743200" cy="365760"/>
-          </a:xfrm>
-          <a:prstGeom prst="rect">
-            <a:avLst/>
-          </a:prstGeom>
-          <a:noFill/>
-          <a:ln/>
-        </p:spPr>
-        <p:txBody>
-          <a:bodyPr wrap="square" rtlCol="0" anchor="ctr"/>
-          <a:lstStyle/>
-          <a:p>
-            <a:pPr indent="0" marL="0">
-              <a:buNone/>
-            </a:pPr>
-            <a:r>
-              <a:rPr lang="en-US" sz="1200" b="1" spc="200" kern="0" dirty="0">
-                <a:solidFill>
-                  <a:srgbClr val="E9A13B"/>
-                </a:solidFill>
-                <a:latin typeface="Calibri" pitchFamily="34" charset="0"/>
-                <a:ea typeface="Calibri" pitchFamily="34" charset="-122"/>
-                <a:cs typeface="Calibri" pitchFamily="34" charset="-120"/>
-              </a:rPr>
-              <a:t>BEELD</a:t>
-            </a:r>
-            <a:endParaRPr lang="en-US" sz="1200" dirty="0"/>
-          </a:p>
-        </p:txBody>
-      </p:sp>
-      <p:sp>
-        <p:nvSpPr>
-          <p:cNvPr id="5" name="Text 3"/>
-          <p:cNvSpPr/>
-          <p:nvPr/>
-        </p:nvSpPr>
-        <p:spPr>
-          <a:xfrm>
-            <a:off x="1188720" y="2103120"/>
-            <a:ext cx="9784080" cy="3200400"/>
-          </a:xfrm>
-          <a:prstGeom prst="rect">
-            <a:avLst/>
-          </a:prstGeom>
-          <a:noFill/>
-          <a:ln/>
-        </p:spPr>
-        <p:txBody>
-          <a:bodyPr wrap="square" rtlCol="0" anchor="t"/>
-          <a:lstStyle/>
-          <a:p>
-            <a:pPr indent="0" marL="0">
-              <a:buNone/>
-            </a:pPr>
-            <a:r>
-              <a:rPr lang="en-US" sz="1800" i="1" dirty="0">
-                <a:solidFill>
-                  <a:srgbClr val="14213D"/>
-                </a:solidFill>
-                <a:latin typeface="Calibri" pitchFamily="34" charset="0"/>
-                <a:ea typeface="Calibri" pitchFamily="34" charset="-122"/>
-                <a:cs typeface="Calibri" pitchFamily="34" charset="-120"/>
-              </a:rPr>
-              <a:t>Werkboekverwijzing, timer 15 minuten</a:t>
-            </a:r>
-            <a:endParaRPr lang="en-US" sz="1800" dirty="0"/>
-          </a:p>
-        </p:txBody>
-      </p:sp>
-      <p:sp>
-        <p:nvSpPr>
-          <p:cNvPr id="6" name="Shape 4"/>
-          <p:cNvSpPr/>
-          <p:nvPr/>
-        </p:nvSpPr>
-        <p:spPr>
-          <a:xfrm>
-            <a:off x="0" y="6172200"/>
-            <a:ext cx="12188952" cy="685800"/>
-          </a:xfrm>
-          <a:prstGeom prst="rect">
-            <a:avLst/>
-          </a:prstGeom>
-          <a:solidFill>
-            <a:srgbClr val="EEF1F6"/>
-          </a:solidFill>
-          <a:ln/>
-        </p:spPr>
-      </p:sp>
-      <p:sp>
-        <p:nvSpPr>
-          <p:cNvPr id="7" name="Text 5"/>
+          <a:ln/>
+        </p:spPr>
+      </p:sp>
+      <p:sp>
+        <p:nvSpPr>
+          <p:cNvPr id="6" name="Text 3"/>
           <p:cNvSpPr/>
           <p:nvPr/>
         </p:nvSpPr>
@@ -4324,7 +4371,7 @@
                 <a:ea typeface="Calibri" pitchFamily="34" charset="-122"/>
                 <a:cs typeface="Calibri" pitchFamily="34" charset="-120"/>
               </a:rPr>
-              <a:t>Spreeknotitie: Tweetallen. Let op de reflex om automatisch naar "verouderd model" te grijpen.</a:t>
+              <a:t>Spreeknotitie: Niet fout, niet verouderd — gewoon nooit opgeschreven.</a:t>
             </a:r>
             <a:endParaRPr lang="en-US" sz="1050" dirty="0"/>
           </a:p>
@@ -4395,98 +4442,140 @@
                 <a:ea typeface="Calibri" pitchFamily="34" charset="-122"/>
                 <a:cs typeface="Calibri" pitchFamily="34" charset="-120"/>
               </a:rPr>
-              <a:t>Drie uitkomsten: wijzig het model, stuur bij, of doe bewust niets</a:t>
+              <a:t>Classificeer vijf afwijkingen</a:t>
             </a:r>
             <a:endParaRPr lang="en-US" sz="2400" dirty="0"/>
           </a:p>
         </p:txBody>
       </p:sp>
-      <p:pic>
-        <p:nvPicPr>
-          <p:cNvPr id="3" name="Image 0" descr="C:\Projecten\eductus-trainingen\CMMN_BPMN_DMN\cursus-bpmn-cmmn-dmn\build\png\deel-20\figuur-20-6-bevindingenrapport-opbouw.png">    </p:cNvPr>
-          <p:cNvPicPr>
-            <a:picLocks noChangeAspect="1"/>
-          </p:cNvPicPr>
-          <p:nvPr/>
-        </p:nvPicPr>
-        <p:blipFill>
-          <a:blip r:embed="rId1"/>
-          <a:stretch>
-            <a:fillRect/>
-          </a:stretch>
-        </p:blipFill>
-        <p:spPr>
-          <a:xfrm>
-            <a:off x="2180279" y="1234440"/>
-            <a:ext cx="7828395" cy="4114800"/>
-          </a:xfrm>
-          <a:prstGeom prst="rect">
-            <a:avLst/>
-          </a:prstGeom>
-        </p:spPr>
-      </p:pic>
-      <p:sp>
-        <p:nvSpPr>
-          <p:cNvPr id="4" name="Text 1"/>
-          <p:cNvSpPr/>
-          <p:nvPr/>
-        </p:nvSpPr>
-        <p:spPr>
-          <a:xfrm>
-            <a:off x="731520" y="5440680"/>
-            <a:ext cx="10698480" cy="457200"/>
-          </a:xfrm>
-          <a:prstGeom prst="rect">
-            <a:avLst/>
-          </a:prstGeom>
-          <a:noFill/>
-          <a:ln/>
-        </p:spPr>
-        <p:txBody>
-          <a:bodyPr wrap="square" rtlCol="0" anchor="ctr"/>
-          <a:lstStyle/>
-          <a:p>
-            <a:pPr algn="ctr" indent="0" marL="0">
-              <a:buNone/>
-            </a:pPr>
-            <a:r>
-              <a:rPr lang="en-US" sz="1200" i="1" dirty="0">
-                <a:solidFill>
-                  <a:srgbClr val="6B7280"/>
-                </a:solidFill>
-                <a:latin typeface="Calibri" pitchFamily="34" charset="0"/>
-                <a:ea typeface="Calibri" pitchFamily="34" charset="-122"/>
-                <a:cs typeface="Calibri" pitchFamily="34" charset="-120"/>
-              </a:rPr>
-              <a:t>Figuur 20.6</a:t>
-            </a:r>
-            <a:endParaRPr lang="en-US" sz="1200" dirty="0"/>
-          </a:p>
-        </p:txBody>
-      </p:sp>
-      <p:sp>
-        <p:nvSpPr>
-          <p:cNvPr id="5" name="Shape 2"/>
-          <p:cNvSpPr/>
-          <p:nvPr/>
-        </p:nvSpPr>
-        <p:spPr>
-          <a:xfrm>
-            <a:off x="0" y="6172200"/>
-            <a:ext cx="12188952" cy="685800"/>
-          </a:xfrm>
-          <a:prstGeom prst="rect">
-            <a:avLst/>
+      <p:sp>
+        <p:nvSpPr>
+          <p:cNvPr id="3" name="Shape 1"/>
+          <p:cNvSpPr/>
+          <p:nvPr/>
+        </p:nvSpPr>
+        <p:spPr>
+          <a:xfrm>
+            <a:off x="822960" y="1371600"/>
+            <a:ext cx="10515600" cy="4206240"/>
+          </a:xfrm>
+          <a:prstGeom prst="roundRect">
+            <a:avLst>
+              <a:gd name="adj" fmla="val 1304"/>
+            </a:avLst>
           </a:prstGeom>
           <a:solidFill>
             <a:srgbClr val="EEF1F6"/>
           </a:solidFill>
-          <a:ln/>
-        </p:spPr>
-      </p:sp>
-      <p:sp>
-        <p:nvSpPr>
-          <p:cNvPr id="6" name="Text 3"/>
+          <a:ln w="12700">
+            <a:solidFill>
+              <a:srgbClr val="D7DCE5"/>
+            </a:solidFill>
+            <a:prstDash val="solid"/>
+          </a:ln>
+        </p:spPr>
+      </p:sp>
+      <p:sp>
+        <p:nvSpPr>
+          <p:cNvPr id="4" name="Text 2"/>
+          <p:cNvSpPr/>
+          <p:nvPr/>
+        </p:nvSpPr>
+        <p:spPr>
+          <a:xfrm>
+            <a:off x="1188720" y="1645920"/>
+            <a:ext cx="2743200" cy="365760"/>
+          </a:xfrm>
+          <a:prstGeom prst="rect">
+            <a:avLst/>
+          </a:prstGeom>
+          <a:noFill/>
+          <a:ln/>
+        </p:spPr>
+        <p:txBody>
+          <a:bodyPr wrap="square" rtlCol="0" anchor="ctr"/>
+          <a:lstStyle/>
+          <a:p>
+            <a:pPr indent="0" marL="0">
+              <a:buNone/>
+            </a:pPr>
+            <a:r>
+              <a:rPr lang="en-US" sz="1200" b="1" spc="200" kern="0" dirty="0">
+                <a:solidFill>
+                  <a:srgbClr val="E9A13B"/>
+                </a:solidFill>
+                <a:latin typeface="Calibri" pitchFamily="34" charset="0"/>
+                <a:ea typeface="Calibri" pitchFamily="34" charset="-122"/>
+                <a:cs typeface="Calibri" pitchFamily="34" charset="-120"/>
+              </a:rPr>
+              <a:t>BEELD</a:t>
+            </a:r>
+            <a:endParaRPr lang="en-US" sz="1200" dirty="0"/>
+          </a:p>
+        </p:txBody>
+      </p:sp>
+      <p:sp>
+        <p:nvSpPr>
+          <p:cNvPr id="5" name="Text 3"/>
+          <p:cNvSpPr/>
+          <p:nvPr/>
+        </p:nvSpPr>
+        <p:spPr>
+          <a:xfrm>
+            <a:off x="1188720" y="2103120"/>
+            <a:ext cx="9784080" cy="3200400"/>
+          </a:xfrm>
+          <a:prstGeom prst="rect">
+            <a:avLst/>
+          </a:prstGeom>
+          <a:noFill/>
+          <a:ln/>
+        </p:spPr>
+        <p:txBody>
+          <a:bodyPr wrap="square" rtlCol="0" anchor="t"/>
+          <a:lstStyle/>
+          <a:p>
+            <a:pPr indent="0" marL="0">
+              <a:buNone/>
+            </a:pPr>
+            <a:r>
+              <a:rPr lang="en-US" sz="1800" i="1" dirty="0">
+                <a:solidFill>
+                  <a:srgbClr val="14213D"/>
+                </a:solidFill>
+                <a:latin typeface="Calibri" pitchFamily="34" charset="0"/>
+                <a:ea typeface="Calibri" pitchFamily="34" charset="-122"/>
+                <a:cs typeface="Calibri" pitchFamily="34" charset="-120"/>
+              </a:rPr>
+              <a:t>Werkboekverwijzing, timer 15 minuten</a:t>
+            </a:r>
+            <a:endParaRPr lang="en-US" sz="1800" dirty="0"/>
+          </a:p>
+        </p:txBody>
+      </p:sp>
+      <p:sp>
+        <p:nvSpPr>
+          <p:cNvPr id="6" name="Shape 4"/>
+          <p:cNvSpPr/>
+          <p:nvPr/>
+        </p:nvSpPr>
+        <p:spPr>
+          <a:xfrm>
+            <a:off x="0" y="6172200"/>
+            <a:ext cx="12188952" cy="685800"/>
+          </a:xfrm>
+          <a:prstGeom prst="rect">
+            <a:avLst/>
+          </a:prstGeom>
+          <a:solidFill>
+            <a:srgbClr val="EEF1F6"/>
+          </a:solidFill>
+          <a:ln/>
+        </p:spPr>
+      </p:sp>
+      <p:sp>
+        <p:nvSpPr>
+          <p:cNvPr id="7" name="Text 5"/>
           <p:cNvSpPr/>
           <p:nvPr/>
         </p:nvSpPr>
@@ -4517,7 +4606,7 @@
                 <a:ea typeface="Calibri" pitchFamily="34" charset="-122"/>
                 <a:cs typeface="Calibri" pitchFamily="34" charset="-120"/>
               </a:rPr>
-              <a:t>Spreeknotitie: Een rapport zonder voorstel is geen resultaat.</a:t>
+              <a:t>Spreeknotitie: Tweetallen. Let op de reflex om automatisch naar "verouderd model" te grijpen.</a:t>
             </a:r>
             <a:endParaRPr lang="en-US" sz="1050" dirty="0"/>
           </a:p>
@@ -4588,140 +4677,98 @@
                 <a:ea typeface="Calibri" pitchFamily="34" charset="-122"/>
                 <a:cs typeface="Calibri" pitchFamily="34" charset="-120"/>
               </a:rPr>
-              <a:t>Wát er gebeurde, niet waarom</a:t>
+              <a:t>Drie uitkomsten: wijzig het model, stuur bij, of doe bewust niets</a:t>
             </a:r>
             <a:endParaRPr lang="en-US" sz="2400" dirty="0"/>
           </a:p>
         </p:txBody>
       </p:sp>
-      <p:sp>
-        <p:nvSpPr>
-          <p:cNvPr id="3" name="Shape 1"/>
-          <p:cNvSpPr/>
-          <p:nvPr/>
-        </p:nvSpPr>
-        <p:spPr>
-          <a:xfrm>
-            <a:off x="822960" y="1371600"/>
-            <a:ext cx="10515600" cy="4206240"/>
-          </a:xfrm>
-          <a:prstGeom prst="roundRect">
-            <a:avLst>
-              <a:gd name="adj" fmla="val 1304"/>
-            </a:avLst>
+      <p:pic>
+        <p:nvPicPr>
+          <p:cNvPr id="3" name="Image 0" descr="C:\Projecten\eductus-trainingen\CMMN_BPMN_DMN\cursus-bpmn-cmmn-dmn\build\png\deel-20\figuur-20-6-bevindingenrapport-opbouw.png">    </p:cNvPr>
+          <p:cNvPicPr>
+            <a:picLocks noChangeAspect="1"/>
+          </p:cNvPicPr>
+          <p:nvPr/>
+        </p:nvPicPr>
+        <p:blipFill>
+          <a:blip r:embed="rId1"/>
+          <a:stretch>
+            <a:fillRect/>
+          </a:stretch>
+        </p:blipFill>
+        <p:spPr>
+          <a:xfrm>
+            <a:off x="2180279" y="1234440"/>
+            <a:ext cx="7828395" cy="4114800"/>
+          </a:xfrm>
+          <a:prstGeom prst="rect">
+            <a:avLst/>
+          </a:prstGeom>
+        </p:spPr>
+      </p:pic>
+      <p:sp>
+        <p:nvSpPr>
+          <p:cNvPr id="4" name="Text 1"/>
+          <p:cNvSpPr/>
+          <p:nvPr/>
+        </p:nvSpPr>
+        <p:spPr>
+          <a:xfrm>
+            <a:off x="731520" y="5440680"/>
+            <a:ext cx="10698480" cy="457200"/>
+          </a:xfrm>
+          <a:prstGeom prst="rect">
+            <a:avLst/>
+          </a:prstGeom>
+          <a:noFill/>
+          <a:ln/>
+        </p:spPr>
+        <p:txBody>
+          <a:bodyPr wrap="square" rtlCol="0" anchor="ctr"/>
+          <a:lstStyle/>
+          <a:p>
+            <a:pPr algn="ctr" indent="0" marL="0">
+              <a:buNone/>
+            </a:pPr>
+            <a:r>
+              <a:rPr lang="en-US" sz="1200" i="1" dirty="0">
+                <a:solidFill>
+                  <a:srgbClr val="6B7280"/>
+                </a:solidFill>
+                <a:latin typeface="Calibri" pitchFamily="34" charset="0"/>
+                <a:ea typeface="Calibri" pitchFamily="34" charset="-122"/>
+                <a:cs typeface="Calibri" pitchFamily="34" charset="-120"/>
+              </a:rPr>
+              <a:t>Figuur 20.6</a:t>
+            </a:r>
+            <a:endParaRPr lang="en-US" sz="1200" dirty="0"/>
+          </a:p>
+        </p:txBody>
+      </p:sp>
+      <p:sp>
+        <p:nvSpPr>
+          <p:cNvPr id="5" name="Shape 2"/>
+          <p:cNvSpPr/>
+          <p:nvPr/>
+        </p:nvSpPr>
+        <p:spPr>
+          <a:xfrm>
+            <a:off x="0" y="6172200"/>
+            <a:ext cx="12188952" cy="685800"/>
+          </a:xfrm>
+          <a:prstGeom prst="rect">
+            <a:avLst/>
           </a:prstGeom>
           <a:solidFill>
             <a:srgbClr val="EEF1F6"/>
           </a:solidFill>
-          <a:ln w="12700">
-            <a:solidFill>
-              <a:srgbClr val="D7DCE5"/>
-            </a:solidFill>
-            <a:prstDash val="solid"/>
-          </a:ln>
-        </p:spPr>
-      </p:sp>
-      <p:sp>
-        <p:nvSpPr>
-          <p:cNvPr id="4" name="Text 2"/>
-          <p:cNvSpPr/>
-          <p:nvPr/>
-        </p:nvSpPr>
-        <p:spPr>
-          <a:xfrm>
-            <a:off x="1188720" y="1645920"/>
-            <a:ext cx="2743200" cy="365760"/>
-          </a:xfrm>
-          <a:prstGeom prst="rect">
-            <a:avLst/>
-          </a:prstGeom>
-          <a:noFill/>
-          <a:ln/>
-        </p:spPr>
-        <p:txBody>
-          <a:bodyPr wrap="square" rtlCol="0" anchor="ctr"/>
-          <a:lstStyle/>
-          <a:p>
-            <a:pPr indent="0" marL="0">
-              <a:buNone/>
-            </a:pPr>
-            <a:r>
-              <a:rPr lang="en-US" sz="1200" b="1" spc="200" kern="0" dirty="0">
-                <a:solidFill>
-                  <a:srgbClr val="E9A13B"/>
-                </a:solidFill>
-                <a:latin typeface="Calibri" pitchFamily="34" charset="0"/>
-                <a:ea typeface="Calibri" pitchFamily="34" charset="-122"/>
-                <a:cs typeface="Calibri" pitchFamily="34" charset="-120"/>
-              </a:rPr>
-              <a:t>BEELD</a:t>
-            </a:r>
-            <a:endParaRPr lang="en-US" sz="1200" dirty="0"/>
-          </a:p>
-        </p:txBody>
-      </p:sp>
-      <p:sp>
-        <p:nvSpPr>
-          <p:cNvPr id="5" name="Text 3"/>
-          <p:cNvSpPr/>
-          <p:nvPr/>
-        </p:nvSpPr>
-        <p:spPr>
-          <a:xfrm>
-            <a:off x="1188720" y="2103120"/>
-            <a:ext cx="9784080" cy="3200400"/>
-          </a:xfrm>
-          <a:prstGeom prst="rect">
-            <a:avLst/>
-          </a:prstGeom>
-          <a:noFill/>
-          <a:ln/>
-        </p:spPr>
-        <p:txBody>
-          <a:bodyPr wrap="square" rtlCol="0" anchor="t"/>
-          <a:lstStyle/>
-          <a:p>
-            <a:pPr indent="0" marL="0">
-              <a:buNone/>
-            </a:pPr>
-            <a:r>
-              <a:rPr lang="en-US" sz="1800" i="1" dirty="0">
-                <a:solidFill>
-                  <a:srgbClr val="14213D"/>
-                </a:solidFill>
-                <a:latin typeface="Calibri" pitchFamily="34" charset="0"/>
-                <a:ea typeface="Calibri" pitchFamily="34" charset="-122"/>
-                <a:cs typeface="Calibri" pitchFamily="34" charset="-120"/>
-              </a:rPr>
-              <a:t>Eén tekstslide</a:t>
-            </a:r>
-            <a:endParaRPr lang="en-US" sz="1800" dirty="0"/>
-          </a:p>
-        </p:txBody>
-      </p:sp>
-      <p:sp>
-        <p:nvSpPr>
-          <p:cNvPr id="6" name="Shape 4"/>
-          <p:cNvSpPr/>
-          <p:nvPr/>
-        </p:nvSpPr>
-        <p:spPr>
-          <a:xfrm>
-            <a:off x="0" y="6172200"/>
-            <a:ext cx="12188952" cy="685800"/>
-          </a:xfrm>
-          <a:prstGeom prst="rect">
-            <a:avLst/>
-          </a:prstGeom>
-          <a:solidFill>
-            <a:srgbClr val="EEF1F6"/>
-          </a:solidFill>
-          <a:ln/>
-        </p:spPr>
-      </p:sp>
-      <p:sp>
-        <p:nvSpPr>
-          <p:cNvPr id="7" name="Text 5"/>
+          <a:ln/>
+        </p:spPr>
+      </p:sp>
+      <p:sp>
+        <p:nvSpPr>
+          <p:cNvPr id="6" name="Text 3"/>
           <p:cNvSpPr/>
           <p:nvPr/>
         </p:nvSpPr>
@@ -4752,7 +4799,7 @@
                 <a:ea typeface="Calibri" pitchFamily="34" charset="-122"/>
                 <a:cs typeface="Calibri" pitchFamily="34" charset="-120"/>
               </a:rPr>
-              <a:t>Spreeknotitie: Voor het waarom heb je deel 12's technieken nog steeds nodig.</a:t>
+              <a:t>Spreeknotitie: Een rapport zonder voorstel is geen resultaat.</a:t>
             </a:r>
             <a:endParaRPr lang="en-US" sz="1050" dirty="0"/>
           </a:p>
@@ -4823,7 +4870,7 @@
                 <a:ea typeface="Calibri" pitchFamily="34" charset="-122"/>
                 <a:cs typeface="Calibri" pitchFamily="34" charset="-120"/>
               </a:rPr>
-              <a:t>Het bevindingenrapport, en de grenzen van mining</a:t>
+              <a:t>Wát er gebeurde, niet waarom</a:t>
             </a:r>
             <a:endParaRPr lang="en-US" sz="2400" dirty="0"/>
           </a:p>
@@ -4928,7 +4975,7 @@
                 <a:ea typeface="Calibri" pitchFamily="34" charset="-122"/>
                 <a:cs typeface="Calibri" pitchFamily="34" charset="-120"/>
               </a:rPr>
-              <a:t>Werkboekverwijzing, inleverdatum</a:t>
+              <a:t>Eén tekstslide</a:t>
             </a:r>
             <a:endParaRPr lang="en-US" sz="1800" dirty="0"/>
           </a:p>
@@ -4987,7 +5034,7 @@
                 <a:ea typeface="Calibri" pitchFamily="34" charset="-122"/>
                 <a:cs typeface="Calibri" pitchFamily="34" charset="-120"/>
               </a:rPr>
-              <a:t>Spreeknotitie: Opdracht 5 als huiswerk; opdracht 6 kort zelfstandig.</a:t>
+              <a:t>Spreeknotitie: Voor het waarom heb je deel 12's technieken nog steeds nodig.</a:t>
             </a:r>
             <a:endParaRPr lang="en-US" sz="1050" dirty="0"/>
           </a:p>
@@ -5058,7 +5105,7 @@
                 <a:ea typeface="Calibri" pitchFamily="34" charset="-122"/>
                 <a:cs typeface="Calibri" pitchFamily="34" charset="-120"/>
               </a:rPr>
-              <a:t>Onderdeel van een driedelige BPMN/CMMN/DMN-cursus</a:t>
+              <a:t>Na vandaag kun je…</a:t>
             </a:r>
             <a:endParaRPr lang="en-US" sz="2400" dirty="0"/>
           </a:p>
@@ -5163,7 +5210,7 @@
                 <a:ea typeface="Calibri" pitchFamily="34" charset="-122"/>
                 <a:cs typeface="Calibri" pitchFamily="34" charset="-120"/>
               </a:rPr>
-              <a:t>Kort overzicht van de drie niveaus, dit deel gemarkeerd</a:t>
+              <a:t>Vijf leerdoelen uit de reader</a:t>
             </a:r>
             <a:endParaRPr lang="en-US" sz="1800" dirty="0"/>
           </a:p>
@@ -5222,7 +5269,7 @@
                 <a:ea typeface="Calibri" pitchFamily="34" charset="-122"/>
                 <a:cs typeface="Calibri" pitchFamily="34" charset="-120"/>
               </a:rPr>
-              <a:t>Spreeknotitie: Alleen tonen bij een volledige-programma-afname.</a:t>
+              <a:t>Spreeknotitie: Kort.</a:t>
             </a:r>
             <a:endParaRPr lang="en-US" sz="1050" dirty="0"/>
           </a:p>
@@ -5293,7 +5340,7 @@
                 <a:ea typeface="Calibri" pitchFamily="34" charset="-122"/>
                 <a:cs typeface="Calibri" pitchFamily="34" charset="-120"/>
               </a:rPr>
-              <a:t>Stellingen</a:t>
+              <a:t>Het bevindingenrapport, en de grenzen van mining</a:t>
             </a:r>
             <a:endParaRPr lang="en-US" sz="2400" dirty="0"/>
           </a:p>
@@ -5398,7 +5445,7 @@
                 <a:ea typeface="Calibri" pitchFamily="34" charset="-122"/>
                 <a:cs typeface="Calibri" pitchFamily="34" charset="-120"/>
               </a:rPr>
-              <a:t>Vier stellingen uit het werkboek</a:t>
+              <a:t>Werkboekverwijzing, inleverdatum</a:t>
             </a:r>
             <a:endParaRPr lang="en-US" sz="1800" dirty="0"/>
           </a:p>
@@ -5457,7 +5504,7 @@
                 <a:ea typeface="Calibri" pitchFamily="34" charset="-122"/>
                 <a:cs typeface="Calibri" pitchFamily="34" charset="-120"/>
               </a:rPr>
-              <a:t>Spreeknotitie: Plenair.</a:t>
+              <a:t>Spreeknotitie: Opdracht 5 als huiswerk; opdracht 6 kort zelfstandig.</a:t>
             </a:r>
             <a:endParaRPr lang="en-US" sz="1050" dirty="0"/>
           </a:p>
@@ -5474,6 +5521,241 @@
 <file path=ppt/slides/slide21.xml><?xml version="1.0" encoding="utf-8"?>
 <p:sld xmlns:a="http://schemas.openxmlformats.org/drawingml/2006/main" xmlns:r="http://schemas.openxmlformats.org/officeDocument/2006/relationships" xmlns:p="http://schemas.openxmlformats.org/presentationml/2006/main">
   <p:cSld name="Slide 21">
+    <p:bg>
+      <p:bgPr>
+        <a:solidFill>
+          <a:srgbClr val="FFFFFF"/>
+        </a:solidFill>
+      </p:bgPr>
+    </p:bg>
+    <p:spTree>
+      <p:nvGrpSpPr>
+        <p:cNvPr id="1" name=""/>
+        <p:cNvGrpSpPr/>
+        <p:nvPr/>
+      </p:nvGrpSpPr>
+      <p:grpSpPr>
+        <a:xfrm>
+          <a:off x="0" y="0"/>
+          <a:ext cx="0" cy="0"/>
+          <a:chOff x="0" y="0"/>
+          <a:chExt cx="0" cy="0"/>
+        </a:xfrm>
+      </p:grpSpPr>
+      <p:sp>
+        <p:nvSpPr>
+          <p:cNvPr id="2" name="Text 0"/>
+          <p:cNvSpPr/>
+          <p:nvPr/>
+        </p:nvSpPr>
+        <p:spPr>
+          <a:xfrm>
+            <a:off x="640080" y="365760"/>
+            <a:ext cx="10881360" cy="731520"/>
+          </a:xfrm>
+          <a:prstGeom prst="rect">
+            <a:avLst/>
+          </a:prstGeom>
+          <a:noFill/>
+          <a:ln/>
+        </p:spPr>
+        <p:txBody>
+          <a:bodyPr wrap="square" rtlCol="0" anchor="ctr"/>
+          <a:lstStyle/>
+          <a:p>
+            <a:pPr indent="0" marL="0">
+              <a:buNone/>
+            </a:pPr>
+            <a:r>
+              <a:rPr lang="en-US" sz="2400" b="1" dirty="0">
+                <a:solidFill>
+                  <a:srgbClr val="14213D"/>
+                </a:solidFill>
+                <a:latin typeface="Calibri" pitchFamily="34" charset="0"/>
+                <a:ea typeface="Calibri" pitchFamily="34" charset="-122"/>
+                <a:cs typeface="Calibri" pitchFamily="34" charset="-120"/>
+              </a:rPr>
+              <a:t>Stellingen</a:t>
+            </a:r>
+            <a:endParaRPr lang="en-US" sz="2400" dirty="0"/>
+          </a:p>
+        </p:txBody>
+      </p:sp>
+      <p:sp>
+        <p:nvSpPr>
+          <p:cNvPr id="3" name="Shape 1"/>
+          <p:cNvSpPr/>
+          <p:nvPr/>
+        </p:nvSpPr>
+        <p:spPr>
+          <a:xfrm>
+            <a:off x="822960" y="1371600"/>
+            <a:ext cx="10515600" cy="4206240"/>
+          </a:xfrm>
+          <a:prstGeom prst="roundRect">
+            <a:avLst>
+              <a:gd name="adj" fmla="val 1304"/>
+            </a:avLst>
+          </a:prstGeom>
+          <a:solidFill>
+            <a:srgbClr val="EEF1F6"/>
+          </a:solidFill>
+          <a:ln w="12700">
+            <a:solidFill>
+              <a:srgbClr val="D7DCE5"/>
+            </a:solidFill>
+            <a:prstDash val="solid"/>
+          </a:ln>
+        </p:spPr>
+      </p:sp>
+      <p:sp>
+        <p:nvSpPr>
+          <p:cNvPr id="4" name="Text 2"/>
+          <p:cNvSpPr/>
+          <p:nvPr/>
+        </p:nvSpPr>
+        <p:spPr>
+          <a:xfrm>
+            <a:off x="1188720" y="1645920"/>
+            <a:ext cx="2743200" cy="365760"/>
+          </a:xfrm>
+          <a:prstGeom prst="rect">
+            <a:avLst/>
+          </a:prstGeom>
+          <a:noFill/>
+          <a:ln/>
+        </p:spPr>
+        <p:txBody>
+          <a:bodyPr wrap="square" rtlCol="0" anchor="ctr"/>
+          <a:lstStyle/>
+          <a:p>
+            <a:pPr indent="0" marL="0">
+              <a:buNone/>
+            </a:pPr>
+            <a:r>
+              <a:rPr lang="en-US" sz="1200" b="1" spc="200" kern="0" dirty="0">
+                <a:solidFill>
+                  <a:srgbClr val="E9A13B"/>
+                </a:solidFill>
+                <a:latin typeface="Calibri" pitchFamily="34" charset="0"/>
+                <a:ea typeface="Calibri" pitchFamily="34" charset="-122"/>
+                <a:cs typeface="Calibri" pitchFamily="34" charset="-120"/>
+              </a:rPr>
+              <a:t>BEELD</a:t>
+            </a:r>
+            <a:endParaRPr lang="en-US" sz="1200" dirty="0"/>
+          </a:p>
+        </p:txBody>
+      </p:sp>
+      <p:sp>
+        <p:nvSpPr>
+          <p:cNvPr id="5" name="Text 3"/>
+          <p:cNvSpPr/>
+          <p:nvPr/>
+        </p:nvSpPr>
+        <p:spPr>
+          <a:xfrm>
+            <a:off x="1188720" y="2103120"/>
+            <a:ext cx="9784080" cy="3200400"/>
+          </a:xfrm>
+          <a:prstGeom prst="rect">
+            <a:avLst/>
+          </a:prstGeom>
+          <a:noFill/>
+          <a:ln/>
+        </p:spPr>
+        <p:txBody>
+          <a:bodyPr wrap="square" rtlCol="0" anchor="t"/>
+          <a:lstStyle/>
+          <a:p>
+            <a:pPr indent="0" marL="0">
+              <a:buNone/>
+            </a:pPr>
+            <a:r>
+              <a:rPr lang="en-US" sz="1800" i="1" dirty="0">
+                <a:solidFill>
+                  <a:srgbClr val="14213D"/>
+                </a:solidFill>
+                <a:latin typeface="Calibri" pitchFamily="34" charset="0"/>
+                <a:ea typeface="Calibri" pitchFamily="34" charset="-122"/>
+                <a:cs typeface="Calibri" pitchFamily="34" charset="-120"/>
+              </a:rPr>
+              <a:t>Vier stellingen uit het werkboek</a:t>
+            </a:r>
+            <a:endParaRPr lang="en-US" sz="1800" dirty="0"/>
+          </a:p>
+        </p:txBody>
+      </p:sp>
+      <p:sp>
+        <p:nvSpPr>
+          <p:cNvPr id="6" name="Shape 4"/>
+          <p:cNvSpPr/>
+          <p:nvPr/>
+        </p:nvSpPr>
+        <p:spPr>
+          <a:xfrm>
+            <a:off x="0" y="6172200"/>
+            <a:ext cx="12188952" cy="685800"/>
+          </a:xfrm>
+          <a:prstGeom prst="rect">
+            <a:avLst/>
+          </a:prstGeom>
+          <a:solidFill>
+            <a:srgbClr val="EEF1F6"/>
+          </a:solidFill>
+          <a:ln/>
+        </p:spPr>
+      </p:sp>
+      <p:sp>
+        <p:nvSpPr>
+          <p:cNvPr id="7" name="Text 5"/>
+          <p:cNvSpPr/>
+          <p:nvPr/>
+        </p:nvSpPr>
+        <p:spPr>
+          <a:xfrm>
+            <a:off x="457200" y="6217920"/>
+            <a:ext cx="11247120" cy="594360"/>
+          </a:xfrm>
+          <a:prstGeom prst="rect">
+            <a:avLst/>
+          </a:prstGeom>
+          <a:noFill/>
+          <a:ln/>
+        </p:spPr>
+        <p:txBody>
+          <a:bodyPr wrap="square" rtlCol="0" anchor="ctr"/>
+          <a:lstStyle/>
+          <a:p>
+            <a:pPr indent="0" marL="0">
+              <a:buNone/>
+            </a:pPr>
+            <a:r>
+              <a:rPr lang="en-US" sz="1050" i="1" dirty="0">
+                <a:solidFill>
+                  <a:srgbClr val="6B7280"/>
+                </a:solidFill>
+                <a:latin typeface="Calibri" pitchFamily="34" charset="0"/>
+                <a:ea typeface="Calibri" pitchFamily="34" charset="-122"/>
+                <a:cs typeface="Calibri" pitchFamily="34" charset="-120"/>
+              </a:rPr>
+              <a:t>Spreeknotitie: Plenair.</a:t>
+            </a:r>
+            <a:endParaRPr lang="en-US" sz="1050" dirty="0"/>
+          </a:p>
+        </p:txBody>
+      </p:sp>
+    </p:spTree>
+  </p:cSld>
+  <p:clrMapOvr>
+    <a:masterClrMapping/>
+  </p:clrMapOvr>
+</p:sld>
+</file>
+
+<file path=ppt/slides/slide22.xml><?xml version="1.0" encoding="utf-8"?>
+<p:sld xmlns:a="http://schemas.openxmlformats.org/drawingml/2006/main" xmlns:r="http://schemas.openxmlformats.org/officeDocument/2006/relationships" xmlns:p="http://schemas.openxmlformats.org/presentationml/2006/main">
+  <p:cSld name="Slide 22">
     <p:bg>
       <p:bgPr>
         <a:solidFill>
@@ -5658,7 +5940,7 @@
                 <a:ea typeface="Calibri" pitchFamily="34" charset="-122"/>
                 <a:cs typeface="Calibri" pitchFamily="34" charset="-120"/>
               </a:rPr>
-              <a:t>Retroductus — inloggen, een log uploaden</a:t>
+              <a:t>Onderdeel van een driedelige BPMN/CMMN/DMN-cursus</a:t>
             </a:r>
             <a:endParaRPr lang="en-US" sz="2400" dirty="0"/>
           </a:p>
@@ -5763,7 +6045,7 @@
                 <a:ea typeface="Calibri" pitchFamily="34" charset="-122"/>
                 <a:cs typeface="Calibri" pitchFamily="34" charset="-120"/>
               </a:rPr>
-              <a:t>Schermafbeelding van het startscherm</a:t>
+              <a:t>Kort overzicht van de drie niveaus, dit deel gemarkeerd</a:t>
             </a:r>
             <a:endParaRPr lang="en-US" sz="1800" dirty="0"/>
           </a:p>
@@ -5822,7 +6104,7 @@
                 <a:ea typeface="Calibri" pitchFamily="34" charset="-122"/>
                 <a:cs typeface="Calibri" pitchFamily="34" charset="-120"/>
               </a:rPr>
-              <a:t>Spreeknotitie: 10 minuten begeleid, net als bij de eerste modelleeromgeving in dit programma.</a:t>
+              <a:t>Spreeknotitie: Alleen tonen bij een volledige-programma-afname.</a:t>
             </a:r>
             <a:endParaRPr lang="en-US" sz="1050" dirty="0"/>
           </a:p>
@@ -5893,98 +6175,140 @@
                 <a:ea typeface="Calibri" pitchFamily="34" charset="-122"/>
                 <a:cs typeface="Calibri" pitchFamily="34" charset="-120"/>
               </a:rPr>
-              <a:t>Discovery · conformance checking · enhancement</a:t>
+              <a:t>Retroductus — inloggen, een log uploaden</a:t>
             </a:r>
             <a:endParaRPr lang="en-US" sz="2400" dirty="0"/>
           </a:p>
         </p:txBody>
       </p:sp>
-      <p:pic>
-        <p:nvPicPr>
-          <p:cNvPr id="3" name="Image 0" descr="C:\Projecten\eductus-trainingen\CMMN_BPMN_DMN\cursus-bpmn-cmmn-dmn\build\png\deel-20\figuur-20-1-drie-soorten-mining.png">    </p:cNvPr>
-          <p:cNvPicPr>
-            <a:picLocks noChangeAspect="1"/>
-          </p:cNvPicPr>
-          <p:nvPr/>
-        </p:nvPicPr>
-        <p:blipFill>
-          <a:blip r:embed="rId1"/>
-          <a:stretch>
-            <a:fillRect/>
-          </a:stretch>
-        </p:blipFill>
-        <p:spPr>
-          <a:xfrm>
-            <a:off x="2162556" y="1234440"/>
-            <a:ext cx="7863840" cy="4079367"/>
-          </a:xfrm>
-          <a:prstGeom prst="rect">
-            <a:avLst/>
-          </a:prstGeom>
-        </p:spPr>
-      </p:pic>
-      <p:sp>
-        <p:nvSpPr>
-          <p:cNvPr id="4" name="Text 1"/>
-          <p:cNvSpPr/>
-          <p:nvPr/>
-        </p:nvSpPr>
-        <p:spPr>
-          <a:xfrm>
-            <a:off x="731520" y="5405247"/>
-            <a:ext cx="10698480" cy="457200"/>
-          </a:xfrm>
-          <a:prstGeom prst="rect">
-            <a:avLst/>
-          </a:prstGeom>
-          <a:noFill/>
-          <a:ln/>
-        </p:spPr>
-        <p:txBody>
-          <a:bodyPr wrap="square" rtlCol="0" anchor="ctr"/>
-          <a:lstStyle/>
-          <a:p>
-            <a:pPr algn="ctr" indent="0" marL="0">
-              <a:buNone/>
-            </a:pPr>
-            <a:r>
-              <a:rPr lang="en-US" sz="1200" i="1" dirty="0">
-                <a:solidFill>
-                  <a:srgbClr val="6B7280"/>
-                </a:solidFill>
-                <a:latin typeface="Calibri" pitchFamily="34" charset="0"/>
-                <a:ea typeface="Calibri" pitchFamily="34" charset="-122"/>
-                <a:cs typeface="Calibri" pitchFamily="34" charset="-120"/>
-              </a:rPr>
-              <a:t>Figuur 20.1</a:t>
-            </a:r>
-            <a:endParaRPr lang="en-US" sz="1200" dirty="0"/>
-          </a:p>
-        </p:txBody>
-      </p:sp>
-      <p:sp>
-        <p:nvSpPr>
-          <p:cNvPr id="5" name="Shape 2"/>
-          <p:cNvSpPr/>
-          <p:nvPr/>
-        </p:nvSpPr>
-        <p:spPr>
-          <a:xfrm>
-            <a:off x="0" y="6172200"/>
-            <a:ext cx="12188952" cy="685800"/>
-          </a:xfrm>
-          <a:prstGeom prst="rect">
-            <a:avLst/>
+      <p:sp>
+        <p:nvSpPr>
+          <p:cNvPr id="3" name="Shape 1"/>
+          <p:cNvSpPr/>
+          <p:nvPr/>
+        </p:nvSpPr>
+        <p:spPr>
+          <a:xfrm>
+            <a:off x="822960" y="1371600"/>
+            <a:ext cx="10515600" cy="4206240"/>
+          </a:xfrm>
+          <a:prstGeom prst="roundRect">
+            <a:avLst>
+              <a:gd name="adj" fmla="val 1304"/>
+            </a:avLst>
           </a:prstGeom>
           <a:solidFill>
             <a:srgbClr val="EEF1F6"/>
           </a:solidFill>
-          <a:ln/>
-        </p:spPr>
-      </p:sp>
-      <p:sp>
-        <p:nvSpPr>
-          <p:cNvPr id="6" name="Text 3"/>
+          <a:ln w="12700">
+            <a:solidFill>
+              <a:srgbClr val="D7DCE5"/>
+            </a:solidFill>
+            <a:prstDash val="solid"/>
+          </a:ln>
+        </p:spPr>
+      </p:sp>
+      <p:sp>
+        <p:nvSpPr>
+          <p:cNvPr id="4" name="Text 2"/>
+          <p:cNvSpPr/>
+          <p:nvPr/>
+        </p:nvSpPr>
+        <p:spPr>
+          <a:xfrm>
+            <a:off x="1188720" y="1645920"/>
+            <a:ext cx="2743200" cy="365760"/>
+          </a:xfrm>
+          <a:prstGeom prst="rect">
+            <a:avLst/>
+          </a:prstGeom>
+          <a:noFill/>
+          <a:ln/>
+        </p:spPr>
+        <p:txBody>
+          <a:bodyPr wrap="square" rtlCol="0" anchor="ctr"/>
+          <a:lstStyle/>
+          <a:p>
+            <a:pPr indent="0" marL="0">
+              <a:buNone/>
+            </a:pPr>
+            <a:r>
+              <a:rPr lang="en-US" sz="1200" b="1" spc="200" kern="0" dirty="0">
+                <a:solidFill>
+                  <a:srgbClr val="E9A13B"/>
+                </a:solidFill>
+                <a:latin typeface="Calibri" pitchFamily="34" charset="0"/>
+                <a:ea typeface="Calibri" pitchFamily="34" charset="-122"/>
+                <a:cs typeface="Calibri" pitchFamily="34" charset="-120"/>
+              </a:rPr>
+              <a:t>BEELD</a:t>
+            </a:r>
+            <a:endParaRPr lang="en-US" sz="1200" dirty="0"/>
+          </a:p>
+        </p:txBody>
+      </p:sp>
+      <p:sp>
+        <p:nvSpPr>
+          <p:cNvPr id="5" name="Text 3"/>
+          <p:cNvSpPr/>
+          <p:nvPr/>
+        </p:nvSpPr>
+        <p:spPr>
+          <a:xfrm>
+            <a:off x="1188720" y="2103120"/>
+            <a:ext cx="9784080" cy="3200400"/>
+          </a:xfrm>
+          <a:prstGeom prst="rect">
+            <a:avLst/>
+          </a:prstGeom>
+          <a:noFill/>
+          <a:ln/>
+        </p:spPr>
+        <p:txBody>
+          <a:bodyPr wrap="square" rtlCol="0" anchor="t"/>
+          <a:lstStyle/>
+          <a:p>
+            <a:pPr indent="0" marL="0">
+              <a:buNone/>
+            </a:pPr>
+            <a:r>
+              <a:rPr lang="en-US" sz="1800" i="1" dirty="0">
+                <a:solidFill>
+                  <a:srgbClr val="14213D"/>
+                </a:solidFill>
+                <a:latin typeface="Calibri" pitchFamily="34" charset="0"/>
+                <a:ea typeface="Calibri" pitchFamily="34" charset="-122"/>
+                <a:cs typeface="Calibri" pitchFamily="34" charset="-120"/>
+              </a:rPr>
+              <a:t>Schermafbeelding van het startscherm</a:t>
+            </a:r>
+            <a:endParaRPr lang="en-US" sz="1800" dirty="0"/>
+          </a:p>
+        </p:txBody>
+      </p:sp>
+      <p:sp>
+        <p:nvSpPr>
+          <p:cNvPr id="6" name="Shape 4"/>
+          <p:cNvSpPr/>
+          <p:nvPr/>
+        </p:nvSpPr>
+        <p:spPr>
+          <a:xfrm>
+            <a:off x="0" y="6172200"/>
+            <a:ext cx="12188952" cy="685800"/>
+          </a:xfrm>
+          <a:prstGeom prst="rect">
+            <a:avLst/>
+          </a:prstGeom>
+          <a:solidFill>
+            <a:srgbClr val="EEF1F6"/>
+          </a:solidFill>
+          <a:ln/>
+        </p:spPr>
+      </p:sp>
+      <p:sp>
+        <p:nvSpPr>
+          <p:cNvPr id="7" name="Text 5"/>
           <p:cNvSpPr/>
           <p:nvPr/>
         </p:nvSpPr>
@@ -6015,7 +6339,7 @@
                 <a:ea typeface="Calibri" pitchFamily="34" charset="-122"/>
                 <a:cs typeface="Calibri" pitchFamily="34" charset="-120"/>
               </a:rPr>
-              <a:t>Spreeknotitie: Vandaag uitsluitend conformance checking.</a:t>
+              <a:t>Spreeknotitie: 10 minuten begeleid, net als bij de eerste modelleeromgeving in dit programma.</a:t>
             </a:r>
             <a:endParaRPr lang="en-US" sz="1050" dirty="0"/>
           </a:p>
@@ -6086,7 +6410,7 @@
                 <a:ea typeface="Calibri" pitchFamily="34" charset="-122"/>
                 <a:cs typeface="Calibri" pitchFamily="34" charset="-120"/>
               </a:rPr>
-              <a:t>Case-ID · activiteit · tijdstempel</a:t>
+              <a:t>Discovery · conformance checking · enhancement</a:t>
             </a:r>
             <a:endParaRPr lang="en-US" sz="2400" dirty="0"/>
           </a:p>
@@ -6094,7 +6418,7 @@
       </p:sp>
       <p:pic>
         <p:nvPicPr>
-          <p:cNvPr id="3" name="Image 0" descr="C:\Projecten\eductus-trainingen\CMMN_BPMN_DMN\cursus-bpmn-cmmn-dmn\build\png\deel-20\figuur-20-2-anatomie-event-log.png">    </p:cNvPr>
+          <p:cNvPr id="3" name="Image 0" descr="C:\Projecten\eductus-trainingen\CMMN_BPMN_DMN\cursus-bpmn-cmmn-dmn\build\png\deel-20\figuur-20-1-drie-soorten-mining.png">    </p:cNvPr>
           <p:cNvPicPr>
             <a:picLocks noChangeAspect="1"/>
           </p:cNvPicPr>
@@ -6108,8 +6432,8 @@
         </p:blipFill>
         <p:spPr>
           <a:xfrm>
-            <a:off x="2420547" y="1234440"/>
-            <a:ext cx="7347857" cy="4114800"/>
+            <a:off x="2162556" y="1234440"/>
+            <a:ext cx="7863840" cy="4079367"/>
           </a:xfrm>
           <a:prstGeom prst="rect">
             <a:avLst/>
@@ -6124,7 +6448,7 @@
         </p:nvSpPr>
         <p:spPr>
           <a:xfrm>
-            <a:off x="731520" y="5440680"/>
+            <a:off x="731520" y="5405247"/>
             <a:ext cx="10698480" cy="457200"/>
           </a:xfrm>
           <a:prstGeom prst="rect">
@@ -6149,7 +6473,7 @@
                 <a:ea typeface="Calibri" pitchFamily="34" charset="-122"/>
                 <a:cs typeface="Calibri" pitchFamily="34" charset="-120"/>
               </a:rPr>
-              <a:t>Figuur 20.2</a:t>
+              <a:t>Figuur 20.1</a:t>
             </a:r>
             <a:endParaRPr lang="en-US" sz="1200" dirty="0"/>
           </a:p>
@@ -6208,7 +6532,7 @@
                 <a:ea typeface="Calibri" pitchFamily="34" charset="-122"/>
                 <a:cs typeface="Calibri" pitchFamily="34" charset="-120"/>
               </a:rPr>
-              <a:t>Spreeknotitie: Drie verplichte kolommen, de rest is aanvullend.</a:t>
+              <a:t>Spreeknotitie: Vandaag uitsluitend conformance checking.</a:t>
             </a:r>
             <a:endParaRPr lang="en-US" sz="1050" dirty="0"/>
           </a:p>
@@ -6279,7 +6603,7 @@
                 <a:ea typeface="Calibri" pitchFamily="34" charset="-122"/>
                 <a:cs typeface="Calibri" pitchFamily="34" charset="-120"/>
               </a:rPr>
-              <a:t>Ontbrekende events · onjuiste tijdstempels · naamgevingsverschillen · grensoverschrijdende cases</a:t>
+              <a:t>Case-ID · activiteit · tijdstempel</a:t>
             </a:r>
             <a:endParaRPr lang="en-US" sz="2400" dirty="0"/>
           </a:p>
@@ -6287,7 +6611,7 @@
       </p:sp>
       <p:pic>
         <p:nvPicPr>
-          <p:cNvPr id="3" name="Image 0" descr="C:\Projecten\eductus-trainingen\CMMN_BPMN_DMN\cursus-bpmn-cmmn-dmn\build\png\deel-20\figuur-20-3-logkwaliteitsproblemen.png">    </p:cNvPr>
+          <p:cNvPr id="3" name="Image 0" descr="C:\Projecten\eductus-trainingen\CMMN_BPMN_DMN\cursus-bpmn-cmmn-dmn\build\png\deel-20\figuur-20-2-anatomie-event-log.png">    </p:cNvPr>
           <p:cNvPicPr>
             <a:picLocks noChangeAspect="1"/>
           </p:cNvPicPr>
@@ -6301,8 +6625,8 @@
         </p:blipFill>
         <p:spPr>
           <a:xfrm>
-            <a:off x="2802636" y="1234440"/>
-            <a:ext cx="6583680" cy="4114800"/>
+            <a:off x="2420547" y="1234440"/>
+            <a:ext cx="7347857" cy="4114800"/>
           </a:xfrm>
           <a:prstGeom prst="rect">
             <a:avLst/>
@@ -6342,7 +6666,7 @@
                 <a:ea typeface="Calibri" pitchFamily="34" charset="-122"/>
                 <a:cs typeface="Calibri" pitchFamily="34" charset="-120"/>
               </a:rPr>
-              <a:t>Figuur 20.3</a:t>
+              <a:t>Figuur 20.2</a:t>
             </a:r>
             <a:endParaRPr lang="en-US" sz="1200" dirty="0"/>
           </a:p>
@@ -6401,7 +6725,7 @@
                 <a:ea typeface="Calibri" pitchFamily="34" charset="-122"/>
                 <a:cs typeface="Calibri" pitchFamily="34" charset="-120"/>
               </a:rPr>
-              <a:t>Spreeknotitie: Dit controleer je vóórdat je iets concludeert.</a:t>
+              <a:t>Spreeknotitie: Drie verplichte kolommen, de rest is aanvullend.</a:t>
             </a:r>
             <a:endParaRPr lang="en-US" sz="1050" dirty="0"/>
           </a:p>
@@ -6472,140 +6796,98 @@
                 <a:ea typeface="Calibri" pitchFamily="34" charset="-122"/>
                 <a:cs typeface="Calibri" pitchFamily="34" charset="-120"/>
               </a:rPr>
-              <a:t>Precieze getallen uit slechte data</a:t>
+              <a:t>Ontbrekende events · onjuiste tijdstempels · naamgevingsverschillen · grensoverschrijdende cases</a:t>
             </a:r>
             <a:endParaRPr lang="en-US" sz="2400" dirty="0"/>
           </a:p>
         </p:txBody>
       </p:sp>
-      <p:sp>
-        <p:nvSpPr>
-          <p:cNvPr id="3" name="Shape 1"/>
-          <p:cNvSpPr/>
-          <p:nvPr/>
-        </p:nvSpPr>
-        <p:spPr>
-          <a:xfrm>
-            <a:off x="822960" y="1371600"/>
-            <a:ext cx="10515600" cy="4206240"/>
-          </a:xfrm>
-          <a:prstGeom prst="roundRect">
-            <a:avLst>
-              <a:gd name="adj" fmla="val 1304"/>
-            </a:avLst>
+      <p:pic>
+        <p:nvPicPr>
+          <p:cNvPr id="3" name="Image 0" descr="C:\Projecten\eductus-trainingen\CMMN_BPMN_DMN\cursus-bpmn-cmmn-dmn\build\png\deel-20\figuur-20-3-logkwaliteitsproblemen.png">    </p:cNvPr>
+          <p:cNvPicPr>
+            <a:picLocks noChangeAspect="1"/>
+          </p:cNvPicPr>
+          <p:nvPr/>
+        </p:nvPicPr>
+        <p:blipFill>
+          <a:blip r:embed="rId1"/>
+          <a:stretch>
+            <a:fillRect/>
+          </a:stretch>
+        </p:blipFill>
+        <p:spPr>
+          <a:xfrm>
+            <a:off x="2802636" y="1234440"/>
+            <a:ext cx="6583680" cy="4114800"/>
+          </a:xfrm>
+          <a:prstGeom prst="rect">
+            <a:avLst/>
+          </a:prstGeom>
+        </p:spPr>
+      </p:pic>
+      <p:sp>
+        <p:nvSpPr>
+          <p:cNvPr id="4" name="Text 1"/>
+          <p:cNvSpPr/>
+          <p:nvPr/>
+        </p:nvSpPr>
+        <p:spPr>
+          <a:xfrm>
+            <a:off x="731520" y="5440680"/>
+            <a:ext cx="10698480" cy="457200"/>
+          </a:xfrm>
+          <a:prstGeom prst="rect">
+            <a:avLst/>
+          </a:prstGeom>
+          <a:noFill/>
+          <a:ln/>
+        </p:spPr>
+        <p:txBody>
+          <a:bodyPr wrap="square" rtlCol="0" anchor="ctr"/>
+          <a:lstStyle/>
+          <a:p>
+            <a:pPr algn="ctr" indent="0" marL="0">
+              <a:buNone/>
+            </a:pPr>
+            <a:r>
+              <a:rPr lang="en-US" sz="1200" i="1" dirty="0">
+                <a:solidFill>
+                  <a:srgbClr val="6B7280"/>
+                </a:solidFill>
+                <a:latin typeface="Calibri" pitchFamily="34" charset="0"/>
+                <a:ea typeface="Calibri" pitchFamily="34" charset="-122"/>
+                <a:cs typeface="Calibri" pitchFamily="34" charset="-120"/>
+              </a:rPr>
+              <a:t>Figuur 20.3</a:t>
+            </a:r>
+            <a:endParaRPr lang="en-US" sz="1200" dirty="0"/>
+          </a:p>
+        </p:txBody>
+      </p:sp>
+      <p:sp>
+        <p:nvSpPr>
+          <p:cNvPr id="5" name="Shape 2"/>
+          <p:cNvSpPr/>
+          <p:nvPr/>
+        </p:nvSpPr>
+        <p:spPr>
+          <a:xfrm>
+            <a:off x="0" y="6172200"/>
+            <a:ext cx="12188952" cy="685800"/>
+          </a:xfrm>
+          <a:prstGeom prst="rect">
+            <a:avLst/>
           </a:prstGeom>
           <a:solidFill>
             <a:srgbClr val="EEF1F6"/>
           </a:solidFill>
-          <a:ln w="12700">
-            <a:solidFill>
-              <a:srgbClr val="D7DCE5"/>
-            </a:solidFill>
-            <a:prstDash val="solid"/>
-          </a:ln>
-        </p:spPr>
-      </p:sp>
-      <p:sp>
-        <p:nvSpPr>
-          <p:cNvPr id="4" name="Text 2"/>
-          <p:cNvSpPr/>
-          <p:nvPr/>
-        </p:nvSpPr>
-        <p:spPr>
-          <a:xfrm>
-            <a:off x="1188720" y="1645920"/>
-            <a:ext cx="2743200" cy="365760"/>
-          </a:xfrm>
-          <a:prstGeom prst="rect">
-            <a:avLst/>
-          </a:prstGeom>
-          <a:noFill/>
-          <a:ln/>
-        </p:spPr>
-        <p:txBody>
-          <a:bodyPr wrap="square" rtlCol="0" anchor="ctr"/>
-          <a:lstStyle/>
-          <a:p>
-            <a:pPr indent="0" marL="0">
-              <a:buNone/>
-            </a:pPr>
-            <a:r>
-              <a:rPr lang="en-US" sz="1200" b="1" spc="200" kern="0" dirty="0">
-                <a:solidFill>
-                  <a:srgbClr val="E9A13B"/>
-                </a:solidFill>
-                <a:latin typeface="Calibri" pitchFamily="34" charset="0"/>
-                <a:ea typeface="Calibri" pitchFamily="34" charset="-122"/>
-                <a:cs typeface="Calibri" pitchFamily="34" charset="-120"/>
-              </a:rPr>
-              <a:t>BEELD</a:t>
-            </a:r>
-            <a:endParaRPr lang="en-US" sz="1200" dirty="0"/>
-          </a:p>
-        </p:txBody>
-      </p:sp>
-      <p:sp>
-        <p:nvSpPr>
-          <p:cNvPr id="5" name="Text 3"/>
-          <p:cNvSpPr/>
-          <p:nvPr/>
-        </p:nvSpPr>
-        <p:spPr>
-          <a:xfrm>
-            <a:off x="1188720" y="2103120"/>
-            <a:ext cx="9784080" cy="3200400"/>
-          </a:xfrm>
-          <a:prstGeom prst="rect">
-            <a:avLst/>
-          </a:prstGeom>
-          <a:noFill/>
-          <a:ln/>
-        </p:spPr>
-        <p:txBody>
-          <a:bodyPr wrap="square" rtlCol="0" anchor="t"/>
-          <a:lstStyle/>
-          <a:p>
-            <a:pPr indent="0" marL="0">
-              <a:buNone/>
-            </a:pPr>
-            <a:r>
-              <a:rPr lang="en-US" sz="1800" i="1" dirty="0">
-                <a:solidFill>
-                  <a:srgbClr val="14213D"/>
-                </a:solidFill>
-                <a:latin typeface="Calibri" pitchFamily="34" charset="0"/>
-                <a:ea typeface="Calibri" pitchFamily="34" charset="-122"/>
-                <a:cs typeface="Calibri" pitchFamily="34" charset="-120"/>
-              </a:rPr>
-              <a:t>Eén tekstslide</a:t>
-            </a:r>
-            <a:endParaRPr lang="en-US" sz="1800" dirty="0"/>
-          </a:p>
-        </p:txBody>
-      </p:sp>
-      <p:sp>
-        <p:nvSpPr>
-          <p:cNvPr id="6" name="Shape 4"/>
-          <p:cNvSpPr/>
-          <p:nvPr/>
-        </p:nvSpPr>
-        <p:spPr>
-          <a:xfrm>
-            <a:off x="0" y="6172200"/>
-            <a:ext cx="12188952" cy="685800"/>
-          </a:xfrm>
-          <a:prstGeom prst="rect">
-            <a:avLst/>
-          </a:prstGeom>
-          <a:solidFill>
-            <a:srgbClr val="EEF1F6"/>
-          </a:solidFill>
-          <a:ln/>
-        </p:spPr>
-      </p:sp>
-      <p:sp>
-        <p:nvSpPr>
-          <p:cNvPr id="7" name="Text 5"/>
+          <a:ln/>
+        </p:spPr>
+      </p:sp>
+      <p:sp>
+        <p:nvSpPr>
+          <p:cNvPr id="6" name="Text 3"/>
           <p:cNvSpPr/>
           <p:nvPr/>
         </p:nvSpPr>
@@ -6636,7 +6918,7 @@
                 <a:ea typeface="Calibri" pitchFamily="34" charset="-122"/>
                 <a:cs typeface="Calibri" pitchFamily="34" charset="-120"/>
               </a:rPr>
-              <a:t>Spreeknotitie: De belangrijkste beroepsfout in dit vak — zet dit hard neer.</a:t>
+              <a:t>Spreeknotitie: Dit controleer je vóórdat je iets concludeert.</a:t>
             </a:r>
             <a:endParaRPr lang="en-US" sz="1050" dirty="0"/>
           </a:p>
@@ -6707,7 +6989,7 @@
                 <a:ea typeface="Calibri" pitchFamily="34" charset="-122"/>
                 <a:cs typeface="Calibri" pitchFamily="34" charset="-120"/>
               </a:rPr>
-              <a:t>Beoordeel een event log op vier ingebouwde problemen</a:t>
+              <a:t>Precieze getallen uit slechte data</a:t>
             </a:r>
             <a:endParaRPr lang="en-US" sz="2400" dirty="0"/>
           </a:p>
@@ -6812,7 +7094,7 @@
                 <a:ea typeface="Calibri" pitchFamily="34" charset="-122"/>
                 <a:cs typeface="Calibri" pitchFamily="34" charset="-120"/>
               </a:rPr>
-              <a:t>Werkboekverwijzing, timer 30 minuten</a:t>
+              <a:t>Eén tekstslide</a:t>
             </a:r>
             <a:endParaRPr lang="en-US" sz="1800" dirty="0"/>
           </a:p>
@@ -6871,7 +7153,7 @@
                 <a:ea typeface="Calibri" pitchFamily="34" charset="-122"/>
                 <a:cs typeface="Calibri" pitchFamily="34" charset="-120"/>
               </a:rPr>
-              <a:t>Spreeknotitie: Individueel, plenair nabespreken. Niet overslaan, ook niet bij tijdsdruk.</a:t>
+              <a:t>Spreeknotitie: De belangrijkste beroepsfout in dit vak — zet dit hard neer.</a:t>
             </a:r>
             <a:endParaRPr lang="en-US" sz="1050" dirty="0"/>
           </a:p>
@@ -6942,98 +7224,140 @@
                 <a:ea typeface="Calibri" pitchFamily="34" charset="-122"/>
                 <a:cs typeface="Calibri" pitchFamily="34" charset="-120"/>
               </a:rPr>
-              <a:t>Conformance checking</a:t>
+              <a:t>Beoordeel een event log op vier ingebouwde problemen</a:t>
             </a:r>
             <a:endParaRPr lang="en-US" sz="2400" dirty="0"/>
           </a:p>
         </p:txBody>
       </p:sp>
-      <p:pic>
-        <p:nvPicPr>
-          <p:cNvPr id="3" name="Image 0" descr="C:\Projecten\eductus-trainingen\CMMN_BPMN_DMN\cursus-bpmn-cmmn-dmn\build\png\deel-20\figuur-20-4-conformance-uitkomst.png">    </p:cNvPr>
-          <p:cNvPicPr>
-            <a:picLocks noChangeAspect="1"/>
-          </p:cNvPicPr>
-          <p:nvPr/>
-        </p:nvPicPr>
-        <p:blipFill>
-          <a:blip r:embed="rId1"/>
-          <a:stretch>
-            <a:fillRect/>
-          </a:stretch>
-        </p:blipFill>
-        <p:spPr>
-          <a:xfrm>
-            <a:off x="2566244" y="1234440"/>
-            <a:ext cx="7056463" cy="4114800"/>
-          </a:xfrm>
-          <a:prstGeom prst="rect">
-            <a:avLst/>
-          </a:prstGeom>
-        </p:spPr>
-      </p:pic>
-      <p:sp>
-        <p:nvSpPr>
-          <p:cNvPr id="4" name="Text 1"/>
-          <p:cNvSpPr/>
-          <p:nvPr/>
-        </p:nvSpPr>
-        <p:spPr>
-          <a:xfrm>
-            <a:off x="731520" y="5440680"/>
-            <a:ext cx="10698480" cy="457200"/>
-          </a:xfrm>
-          <a:prstGeom prst="rect">
-            <a:avLst/>
-          </a:prstGeom>
-          <a:noFill/>
-          <a:ln/>
-        </p:spPr>
-        <p:txBody>
-          <a:bodyPr wrap="square" rtlCol="0" anchor="ctr"/>
-          <a:lstStyle/>
-          <a:p>
-            <a:pPr algn="ctr" indent="0" marL="0">
-              <a:buNone/>
-            </a:pPr>
-            <a:r>
-              <a:rPr lang="en-US" sz="1200" i="1" dirty="0">
-                <a:solidFill>
-                  <a:srgbClr val="6B7280"/>
-                </a:solidFill>
-                <a:latin typeface="Calibri" pitchFamily="34" charset="0"/>
-                <a:ea typeface="Calibri" pitchFamily="34" charset="-122"/>
-                <a:cs typeface="Calibri" pitchFamily="34" charset="-120"/>
-              </a:rPr>
-              <a:t>leeg</a:t>
-            </a:r>
-            <a:endParaRPr lang="en-US" sz="1200" dirty="0"/>
-          </a:p>
-        </p:txBody>
-      </p:sp>
-      <p:sp>
-        <p:nvSpPr>
-          <p:cNvPr id="5" name="Shape 2"/>
-          <p:cNvSpPr/>
-          <p:nvPr/>
-        </p:nvSpPr>
-        <p:spPr>
-          <a:xfrm>
-            <a:off x="0" y="6172200"/>
-            <a:ext cx="12188952" cy="685800"/>
-          </a:xfrm>
-          <a:prstGeom prst="rect">
-            <a:avLst/>
+      <p:sp>
+        <p:nvSpPr>
+          <p:cNvPr id="3" name="Shape 1"/>
+          <p:cNvSpPr/>
+          <p:nvPr/>
+        </p:nvSpPr>
+        <p:spPr>
+          <a:xfrm>
+            <a:off x="822960" y="1371600"/>
+            <a:ext cx="10515600" cy="4206240"/>
+          </a:xfrm>
+          <a:prstGeom prst="roundRect">
+            <a:avLst>
+              <a:gd name="adj" fmla="val 1304"/>
+            </a:avLst>
           </a:prstGeom>
           <a:solidFill>
             <a:srgbClr val="EEF1F6"/>
           </a:solidFill>
-          <a:ln/>
-        </p:spPr>
-      </p:sp>
-      <p:sp>
-        <p:nvSpPr>
-          <p:cNvPr id="6" name="Text 3"/>
+          <a:ln w="12700">
+            <a:solidFill>
+              <a:srgbClr val="D7DCE5"/>
+            </a:solidFill>
+            <a:prstDash val="solid"/>
+          </a:ln>
+        </p:spPr>
+      </p:sp>
+      <p:sp>
+        <p:nvSpPr>
+          <p:cNvPr id="4" name="Text 2"/>
+          <p:cNvSpPr/>
+          <p:nvPr/>
+        </p:nvSpPr>
+        <p:spPr>
+          <a:xfrm>
+            <a:off x="1188720" y="1645920"/>
+            <a:ext cx="2743200" cy="365760"/>
+          </a:xfrm>
+          <a:prstGeom prst="rect">
+            <a:avLst/>
+          </a:prstGeom>
+          <a:noFill/>
+          <a:ln/>
+        </p:spPr>
+        <p:txBody>
+          <a:bodyPr wrap="square" rtlCol="0" anchor="ctr"/>
+          <a:lstStyle/>
+          <a:p>
+            <a:pPr indent="0" marL="0">
+              <a:buNone/>
+            </a:pPr>
+            <a:r>
+              <a:rPr lang="en-US" sz="1200" b="1" spc="200" kern="0" dirty="0">
+                <a:solidFill>
+                  <a:srgbClr val="E9A13B"/>
+                </a:solidFill>
+                <a:latin typeface="Calibri" pitchFamily="34" charset="0"/>
+                <a:ea typeface="Calibri" pitchFamily="34" charset="-122"/>
+                <a:cs typeface="Calibri" pitchFamily="34" charset="-120"/>
+              </a:rPr>
+              <a:t>BEELD</a:t>
+            </a:r>
+            <a:endParaRPr lang="en-US" sz="1200" dirty="0"/>
+          </a:p>
+        </p:txBody>
+      </p:sp>
+      <p:sp>
+        <p:nvSpPr>
+          <p:cNvPr id="5" name="Text 3"/>
+          <p:cNvSpPr/>
+          <p:nvPr/>
+        </p:nvSpPr>
+        <p:spPr>
+          <a:xfrm>
+            <a:off x="1188720" y="2103120"/>
+            <a:ext cx="9784080" cy="3200400"/>
+          </a:xfrm>
+          <a:prstGeom prst="rect">
+            <a:avLst/>
+          </a:prstGeom>
+          <a:noFill/>
+          <a:ln/>
+        </p:spPr>
+        <p:txBody>
+          <a:bodyPr wrap="square" rtlCol="0" anchor="t"/>
+          <a:lstStyle/>
+          <a:p>
+            <a:pPr indent="0" marL="0">
+              <a:buNone/>
+            </a:pPr>
+            <a:r>
+              <a:rPr lang="en-US" sz="1800" i="1" dirty="0">
+                <a:solidFill>
+                  <a:srgbClr val="14213D"/>
+                </a:solidFill>
+                <a:latin typeface="Calibri" pitchFamily="34" charset="0"/>
+                <a:ea typeface="Calibri" pitchFamily="34" charset="-122"/>
+                <a:cs typeface="Calibri" pitchFamily="34" charset="-120"/>
+              </a:rPr>
+              <a:t>Werkboekverwijzing, timer 30 minuten</a:t>
+            </a:r>
+            <a:endParaRPr lang="en-US" sz="1800" dirty="0"/>
+          </a:p>
+        </p:txBody>
+      </p:sp>
+      <p:sp>
+        <p:nvSpPr>
+          <p:cNvPr id="6" name="Shape 4"/>
+          <p:cNvSpPr/>
+          <p:nvPr/>
+        </p:nvSpPr>
+        <p:spPr>
+          <a:xfrm>
+            <a:off x="0" y="6172200"/>
+            <a:ext cx="12188952" cy="685800"/>
+          </a:xfrm>
+          <a:prstGeom prst="rect">
+            <a:avLst/>
+          </a:prstGeom>
+          <a:solidFill>
+            <a:srgbClr val="EEF1F6"/>
+          </a:solidFill>
+          <a:ln/>
+        </p:spPr>
+      </p:sp>
+      <p:sp>
+        <p:nvSpPr>
+          <p:cNvPr id="7" name="Text 5"/>
           <p:cNvSpPr/>
           <p:nvPr/>
         </p:nvSpPr>
@@ -7064,7 +7388,7 @@
                 <a:ea typeface="Calibri" pitchFamily="34" charset="-122"/>
                 <a:cs typeface="Calibri" pitchFamily="34" charset="-120"/>
               </a:rPr>
-              <a:t>Spreeknotitie: Introductie.</a:t>
+              <a:t>Spreeknotitie: Individueel, plenair nabespreken. Niet overslaan, ook niet bij tijdsdruk.</a:t>
             </a:r>
             <a:endParaRPr lang="en-US" sz="1050" dirty="0"/>
           </a:p>

</xml_diff>